<commit_message>
[FHIR-56006](https://jira.hl7.org/browse/FHIR-56006): Clarified reporting and exchange use cases
</commit_message>
<xml_diff>
--- a/input/images/source/DEQM IG Diagram.pptx
+++ b/input/images/source/DEQM IG Diagram.pptx
@@ -4,6 +4,9 @@
   <p:sldMasterIdLst>
     <p:sldMasterId id="2147483648" r:id="rId1"/>
   </p:sldMasterIdLst>
+  <p:notesMasterIdLst>
+    <p:notesMasterId r:id="rId13"/>
+  </p:notesMasterIdLst>
   <p:sldIdLst>
     <p:sldId id="261" r:id="rId2"/>
     <p:sldId id="259" r:id="rId3"/>
@@ -12,6 +15,10 @@
     <p:sldId id="4863" r:id="rId6"/>
     <p:sldId id="4864" r:id="rId7"/>
     <p:sldId id="4865" r:id="rId8"/>
+    <p:sldId id="257" r:id="rId9"/>
+    <p:sldId id="262" r:id="rId10"/>
+    <p:sldId id="258" r:id="rId11"/>
+    <p:sldId id="4866" r:id="rId12"/>
   </p:sldIdLst>
   <p:sldSz cx="12192000" cy="6858000"/>
   <p:notesSz cx="6858000" cy="9144000"/>
@@ -118,6 +125,439 @@
 </p:presentation>
 </file>
 
+<file path=ppt/notesMasters/notesMaster1.xml><?xml version="1.0" encoding="utf-8"?>
+<p:notesMaster xmlns:a="http://schemas.openxmlformats.org/drawingml/2006/main" xmlns:r="http://schemas.openxmlformats.org/officeDocument/2006/relationships" xmlns:p="http://schemas.openxmlformats.org/presentationml/2006/main">
+  <p:cSld>
+    <p:bg>
+      <p:bgRef idx="1001">
+        <a:schemeClr val="bg1"/>
+      </p:bgRef>
+    </p:bg>
+    <p:spTree>
+      <p:nvGrpSpPr>
+        <p:cNvPr id="1" name=""/>
+        <p:cNvGrpSpPr/>
+        <p:nvPr/>
+      </p:nvGrpSpPr>
+      <p:grpSpPr>
+        <a:xfrm>
+          <a:off x="0" y="0"/>
+          <a:ext cx="0" cy="0"/>
+          <a:chOff x="0" y="0"/>
+          <a:chExt cx="0" cy="0"/>
+        </a:xfrm>
+      </p:grpSpPr>
+      <p:sp>
+        <p:nvSpPr>
+          <p:cNvPr id="2" name="Header Placeholder 1"/>
+          <p:cNvSpPr>
+            <a:spLocks noGrp="1"/>
+          </p:cNvSpPr>
+          <p:nvPr>
+            <p:ph type="hdr" sz="quarter"/>
+          </p:nvPr>
+        </p:nvSpPr>
+        <p:spPr>
+          <a:xfrm>
+            <a:off x="0" y="0"/>
+            <a:ext cx="2971800" cy="458788"/>
+          </a:xfrm>
+          <a:prstGeom prst="rect">
+            <a:avLst/>
+          </a:prstGeom>
+        </p:spPr>
+        <p:txBody>
+          <a:bodyPr vert="horz" lIns="91440" tIns="45720" rIns="91440" bIns="45720" rtlCol="0"/>
+          <a:lstStyle>
+            <a:lvl1pPr algn="l">
+              <a:defRPr sz="1200"/>
+            </a:lvl1pPr>
+          </a:lstStyle>
+          <a:p>
+            <a:endParaRPr lang="en-US"/>
+          </a:p>
+        </p:txBody>
+      </p:sp>
+      <p:sp>
+        <p:nvSpPr>
+          <p:cNvPr id="3" name="Date Placeholder 2"/>
+          <p:cNvSpPr>
+            <a:spLocks noGrp="1"/>
+          </p:cNvSpPr>
+          <p:nvPr>
+            <p:ph type="dt" idx="1"/>
+          </p:nvPr>
+        </p:nvSpPr>
+        <p:spPr>
+          <a:xfrm>
+            <a:off x="3884613" y="0"/>
+            <a:ext cx="2971800" cy="458788"/>
+          </a:xfrm>
+          <a:prstGeom prst="rect">
+            <a:avLst/>
+          </a:prstGeom>
+        </p:spPr>
+        <p:txBody>
+          <a:bodyPr vert="horz" lIns="91440" tIns="45720" rIns="91440" bIns="45720" rtlCol="0"/>
+          <a:lstStyle>
+            <a:lvl1pPr algn="r">
+              <a:defRPr sz="1200"/>
+            </a:lvl1pPr>
+          </a:lstStyle>
+          <a:p>
+            <a:fld id="{8003B671-C942-4B48-A4AA-E54C0E868887}" type="datetimeFigureOut">
+              <a:rPr lang="en-US" smtClean="0"/>
+              <a:t>3/15/2026</a:t>
+            </a:fld>
+            <a:endParaRPr lang="en-US"/>
+          </a:p>
+        </p:txBody>
+      </p:sp>
+      <p:sp>
+        <p:nvSpPr>
+          <p:cNvPr id="4" name="Slide Image Placeholder 3"/>
+          <p:cNvSpPr>
+            <a:spLocks noGrp="1" noRot="1" noChangeAspect="1"/>
+          </p:cNvSpPr>
+          <p:nvPr>
+            <p:ph type="sldImg" idx="2"/>
+          </p:nvPr>
+        </p:nvSpPr>
+        <p:spPr>
+          <a:xfrm>
+            <a:off x="685800" y="1143000"/>
+            <a:ext cx="5486400" cy="3086100"/>
+          </a:xfrm>
+          <a:prstGeom prst="rect">
+            <a:avLst/>
+          </a:prstGeom>
+          <a:noFill/>
+          <a:ln w="12700">
+            <a:solidFill>
+              <a:prstClr val="black"/>
+            </a:solidFill>
+          </a:ln>
+        </p:spPr>
+        <p:txBody>
+          <a:bodyPr vert="horz" lIns="91440" tIns="45720" rIns="91440" bIns="45720" rtlCol="0" anchor="ctr"/>
+          <a:lstStyle/>
+          <a:p>
+            <a:endParaRPr lang="en-US"/>
+          </a:p>
+        </p:txBody>
+      </p:sp>
+      <p:sp>
+        <p:nvSpPr>
+          <p:cNvPr id="5" name="Notes Placeholder 4"/>
+          <p:cNvSpPr>
+            <a:spLocks noGrp="1"/>
+          </p:cNvSpPr>
+          <p:nvPr>
+            <p:ph type="body" sz="quarter" idx="3"/>
+          </p:nvPr>
+        </p:nvSpPr>
+        <p:spPr>
+          <a:xfrm>
+            <a:off x="685800" y="4400550"/>
+            <a:ext cx="5486400" cy="3600450"/>
+          </a:xfrm>
+          <a:prstGeom prst="rect">
+            <a:avLst/>
+          </a:prstGeom>
+        </p:spPr>
+        <p:txBody>
+          <a:bodyPr vert="horz" lIns="91440" tIns="45720" rIns="91440" bIns="45720" rtlCol="0"/>
+          <a:lstStyle/>
+          <a:p>
+            <a:pPr lvl="0"/>
+            <a:r>
+              <a:rPr lang="en-US"/>
+              <a:t>Click to edit Master text styles</a:t>
+            </a:r>
+          </a:p>
+          <a:p>
+            <a:pPr lvl="1"/>
+            <a:r>
+              <a:rPr lang="en-US"/>
+              <a:t>Second level</a:t>
+            </a:r>
+          </a:p>
+          <a:p>
+            <a:pPr lvl="2"/>
+            <a:r>
+              <a:rPr lang="en-US"/>
+              <a:t>Third level</a:t>
+            </a:r>
+          </a:p>
+          <a:p>
+            <a:pPr lvl="3"/>
+            <a:r>
+              <a:rPr lang="en-US"/>
+              <a:t>Fourth level</a:t>
+            </a:r>
+          </a:p>
+          <a:p>
+            <a:pPr lvl="4"/>
+            <a:r>
+              <a:rPr lang="en-US"/>
+              <a:t>Fifth level</a:t>
+            </a:r>
+          </a:p>
+        </p:txBody>
+      </p:sp>
+      <p:sp>
+        <p:nvSpPr>
+          <p:cNvPr id="6" name="Footer Placeholder 5"/>
+          <p:cNvSpPr>
+            <a:spLocks noGrp="1"/>
+          </p:cNvSpPr>
+          <p:nvPr>
+            <p:ph type="ftr" sz="quarter" idx="4"/>
+          </p:nvPr>
+        </p:nvSpPr>
+        <p:spPr>
+          <a:xfrm>
+            <a:off x="0" y="8685213"/>
+            <a:ext cx="2971800" cy="458787"/>
+          </a:xfrm>
+          <a:prstGeom prst="rect">
+            <a:avLst/>
+          </a:prstGeom>
+        </p:spPr>
+        <p:txBody>
+          <a:bodyPr vert="horz" lIns="91440" tIns="45720" rIns="91440" bIns="45720" rtlCol="0" anchor="b"/>
+          <a:lstStyle>
+            <a:lvl1pPr algn="l">
+              <a:defRPr sz="1200"/>
+            </a:lvl1pPr>
+          </a:lstStyle>
+          <a:p>
+            <a:endParaRPr lang="en-US"/>
+          </a:p>
+        </p:txBody>
+      </p:sp>
+      <p:sp>
+        <p:nvSpPr>
+          <p:cNvPr id="7" name="Slide Number Placeholder 6"/>
+          <p:cNvSpPr>
+            <a:spLocks noGrp="1"/>
+          </p:cNvSpPr>
+          <p:nvPr>
+            <p:ph type="sldNum" sz="quarter" idx="5"/>
+          </p:nvPr>
+        </p:nvSpPr>
+        <p:spPr>
+          <a:xfrm>
+            <a:off x="3884613" y="8685213"/>
+            <a:ext cx="2971800" cy="458787"/>
+          </a:xfrm>
+          <a:prstGeom prst="rect">
+            <a:avLst/>
+          </a:prstGeom>
+        </p:spPr>
+        <p:txBody>
+          <a:bodyPr vert="horz" lIns="91440" tIns="45720" rIns="91440" bIns="45720" rtlCol="0" anchor="b"/>
+          <a:lstStyle>
+            <a:lvl1pPr algn="r">
+              <a:defRPr sz="1200"/>
+            </a:lvl1pPr>
+          </a:lstStyle>
+          <a:p>
+            <a:fld id="{33365719-4AE1-4AF6-9D49-D80E803B6CA6}" type="slidenum">
+              <a:rPr lang="en-US" smtClean="0"/>
+              <a:t>‹#›</a:t>
+            </a:fld>
+            <a:endParaRPr lang="en-US"/>
+          </a:p>
+        </p:txBody>
+      </p:sp>
+    </p:spTree>
+    <p:extLst>
+      <p:ext uri="{BB962C8B-B14F-4D97-AF65-F5344CB8AC3E}">
+        <p14:creationId xmlns:p14="http://schemas.microsoft.com/office/powerpoint/2010/main" val="6799256"/>
+      </p:ext>
+    </p:extLst>
+  </p:cSld>
+  <p:clrMap bg1="lt1" tx1="dk1" bg2="lt2" tx2="dk2" accent1="accent1" accent2="accent2" accent3="accent3" accent4="accent4" accent5="accent5" accent6="accent6" hlink="hlink" folHlink="folHlink"/>
+  <p:notesStyle>
+    <a:lvl1pPr marL="0" algn="l" defTabSz="914400" rtl="0" eaLnBrk="1" latinLnBrk="0" hangingPunct="1">
+      <a:defRPr sz="1200" kern="1200">
+        <a:solidFill>
+          <a:schemeClr val="tx1"/>
+        </a:solidFill>
+        <a:latin typeface="+mn-lt"/>
+        <a:ea typeface="+mn-ea"/>
+        <a:cs typeface="+mn-cs"/>
+      </a:defRPr>
+    </a:lvl1pPr>
+    <a:lvl2pPr marL="457200" algn="l" defTabSz="914400" rtl="0" eaLnBrk="1" latinLnBrk="0" hangingPunct="1">
+      <a:defRPr sz="1200" kern="1200">
+        <a:solidFill>
+          <a:schemeClr val="tx1"/>
+        </a:solidFill>
+        <a:latin typeface="+mn-lt"/>
+        <a:ea typeface="+mn-ea"/>
+        <a:cs typeface="+mn-cs"/>
+      </a:defRPr>
+    </a:lvl2pPr>
+    <a:lvl3pPr marL="914400" algn="l" defTabSz="914400" rtl="0" eaLnBrk="1" latinLnBrk="0" hangingPunct="1">
+      <a:defRPr sz="1200" kern="1200">
+        <a:solidFill>
+          <a:schemeClr val="tx1"/>
+        </a:solidFill>
+        <a:latin typeface="+mn-lt"/>
+        <a:ea typeface="+mn-ea"/>
+        <a:cs typeface="+mn-cs"/>
+      </a:defRPr>
+    </a:lvl3pPr>
+    <a:lvl4pPr marL="1371600" algn="l" defTabSz="914400" rtl="0" eaLnBrk="1" latinLnBrk="0" hangingPunct="1">
+      <a:defRPr sz="1200" kern="1200">
+        <a:solidFill>
+          <a:schemeClr val="tx1"/>
+        </a:solidFill>
+        <a:latin typeface="+mn-lt"/>
+        <a:ea typeface="+mn-ea"/>
+        <a:cs typeface="+mn-cs"/>
+      </a:defRPr>
+    </a:lvl4pPr>
+    <a:lvl5pPr marL="1828800" algn="l" defTabSz="914400" rtl="0" eaLnBrk="1" latinLnBrk="0" hangingPunct="1">
+      <a:defRPr sz="1200" kern="1200">
+        <a:solidFill>
+          <a:schemeClr val="tx1"/>
+        </a:solidFill>
+        <a:latin typeface="+mn-lt"/>
+        <a:ea typeface="+mn-ea"/>
+        <a:cs typeface="+mn-cs"/>
+      </a:defRPr>
+    </a:lvl5pPr>
+    <a:lvl6pPr marL="2286000" algn="l" defTabSz="914400" rtl="0" eaLnBrk="1" latinLnBrk="0" hangingPunct="1">
+      <a:defRPr sz="1200" kern="1200">
+        <a:solidFill>
+          <a:schemeClr val="tx1"/>
+        </a:solidFill>
+        <a:latin typeface="+mn-lt"/>
+        <a:ea typeface="+mn-ea"/>
+        <a:cs typeface="+mn-cs"/>
+      </a:defRPr>
+    </a:lvl6pPr>
+    <a:lvl7pPr marL="2743200" algn="l" defTabSz="914400" rtl="0" eaLnBrk="1" latinLnBrk="0" hangingPunct="1">
+      <a:defRPr sz="1200" kern="1200">
+        <a:solidFill>
+          <a:schemeClr val="tx1"/>
+        </a:solidFill>
+        <a:latin typeface="+mn-lt"/>
+        <a:ea typeface="+mn-ea"/>
+        <a:cs typeface="+mn-cs"/>
+      </a:defRPr>
+    </a:lvl7pPr>
+    <a:lvl8pPr marL="3200400" algn="l" defTabSz="914400" rtl="0" eaLnBrk="1" latinLnBrk="0" hangingPunct="1">
+      <a:defRPr sz="1200" kern="1200">
+        <a:solidFill>
+          <a:schemeClr val="tx1"/>
+        </a:solidFill>
+        <a:latin typeface="+mn-lt"/>
+        <a:ea typeface="+mn-ea"/>
+        <a:cs typeface="+mn-cs"/>
+      </a:defRPr>
+    </a:lvl8pPr>
+    <a:lvl9pPr marL="3657600" algn="l" defTabSz="914400" rtl="0" eaLnBrk="1" latinLnBrk="0" hangingPunct="1">
+      <a:defRPr sz="1200" kern="1200">
+        <a:solidFill>
+          <a:schemeClr val="tx1"/>
+        </a:solidFill>
+        <a:latin typeface="+mn-lt"/>
+        <a:ea typeface="+mn-ea"/>
+        <a:cs typeface="+mn-cs"/>
+      </a:defRPr>
+    </a:lvl9pPr>
+  </p:notesStyle>
+</p:notesMaster>
+</file>
+
+<file path=ppt/notesSlides/notesSlide1.xml><?xml version="1.0" encoding="utf-8"?>
+<p:notes xmlns:a="http://schemas.openxmlformats.org/drawingml/2006/main" xmlns:r="http://schemas.openxmlformats.org/officeDocument/2006/relationships" xmlns:p="http://schemas.openxmlformats.org/presentationml/2006/main">
+  <p:cSld>
+    <p:spTree>
+      <p:nvGrpSpPr>
+        <p:cNvPr id="1" name=""/>
+        <p:cNvGrpSpPr/>
+        <p:nvPr/>
+      </p:nvGrpSpPr>
+      <p:grpSpPr>
+        <a:xfrm>
+          <a:off x="0" y="0"/>
+          <a:ext cx="0" cy="0"/>
+          <a:chOff x="0" y="0"/>
+          <a:chExt cx="0" cy="0"/>
+        </a:xfrm>
+      </p:grpSpPr>
+      <p:sp>
+        <p:nvSpPr>
+          <p:cNvPr id="2" name="Slide Image Placeholder 1"/>
+          <p:cNvSpPr>
+            <a:spLocks noGrp="1" noRot="1" noChangeAspect="1"/>
+          </p:cNvSpPr>
+          <p:nvPr>
+            <p:ph type="sldImg"/>
+          </p:nvPr>
+        </p:nvSpPr>
+        <p:spPr/>
+      </p:sp>
+      <p:sp>
+        <p:nvSpPr>
+          <p:cNvPr id="3" name="Notes Placeholder 2"/>
+          <p:cNvSpPr>
+            <a:spLocks noGrp="1"/>
+          </p:cNvSpPr>
+          <p:nvPr>
+            <p:ph type="body" idx="1"/>
+          </p:nvPr>
+        </p:nvSpPr>
+        <p:spPr/>
+        <p:txBody>
+          <a:bodyPr/>
+          <a:lstStyle/>
+          <a:p>
+            <a:endParaRPr lang="en-US" dirty="0"/>
+          </a:p>
+        </p:txBody>
+      </p:sp>
+      <p:sp>
+        <p:nvSpPr>
+          <p:cNvPr id="4" name="Slide Number Placeholder 3"/>
+          <p:cNvSpPr>
+            <a:spLocks noGrp="1"/>
+          </p:cNvSpPr>
+          <p:nvPr>
+            <p:ph type="sldNum" sz="quarter" idx="5"/>
+          </p:nvPr>
+        </p:nvSpPr>
+        <p:spPr/>
+        <p:txBody>
+          <a:bodyPr/>
+          <a:lstStyle/>
+          <a:p>
+            <a:fld id="{1F4C345F-24A0-4939-85DF-69C6AA67F65C}" type="slidenum">
+              <a:rPr lang="en-US" smtClean="0"/>
+              <a:t>9</a:t>
+            </a:fld>
+            <a:endParaRPr lang="en-US"/>
+          </a:p>
+        </p:txBody>
+      </p:sp>
+    </p:spTree>
+    <p:extLst>
+      <p:ext uri="{BB962C8B-B14F-4D97-AF65-F5344CB8AC3E}">
+        <p14:creationId xmlns:p14="http://schemas.microsoft.com/office/powerpoint/2010/main" val="2298871777"/>
+      </p:ext>
+    </p:extLst>
+  </p:cSld>
+  <p:clrMapOvr>
+    <a:masterClrMapping/>
+  </p:clrMapOvr>
+</p:notes>
+</file>
+
 <file path=ppt/slideLayouts/slideLayout1.xml><?xml version="1.0" encoding="utf-8"?>
 <p:sldLayout xmlns:a="http://schemas.openxmlformats.org/drawingml/2006/main" xmlns:r="http://schemas.openxmlformats.org/officeDocument/2006/relationships" xmlns:p="http://schemas.openxmlformats.org/presentationml/2006/main" type="title" preserve="1">
   <p:cSld name="Title Slide">
@@ -265,7 +705,7 @@
           <a:p>
             <a:fld id="{A1C33FE8-8021-45D4-B0C5-0B5FC73F013B}" type="datetimeFigureOut">
               <a:rPr lang="en-US" smtClean="0"/>
-              <a:t>4/9/2025</a:t>
+              <a:t>3/15/2026</a:t>
             </a:fld>
             <a:endParaRPr lang="en-US"/>
           </a:p>
@@ -463,7 +903,7 @@
           <a:p>
             <a:fld id="{A1C33FE8-8021-45D4-B0C5-0B5FC73F013B}" type="datetimeFigureOut">
               <a:rPr lang="en-US" smtClean="0"/>
-              <a:t>4/9/2025</a:t>
+              <a:t>3/15/2026</a:t>
             </a:fld>
             <a:endParaRPr lang="en-US"/>
           </a:p>
@@ -671,7 +1111,7 @@
           <a:p>
             <a:fld id="{A1C33FE8-8021-45D4-B0C5-0B5FC73F013B}" type="datetimeFigureOut">
               <a:rPr lang="en-US" smtClean="0"/>
-              <a:t>4/9/2025</a:t>
+              <a:t>3/15/2026</a:t>
             </a:fld>
             <a:endParaRPr lang="en-US"/>
           </a:p>
@@ -1815,7 +2255,7 @@
           <a:p>
             <a:fld id="{A1C33FE8-8021-45D4-B0C5-0B5FC73F013B}" type="datetimeFigureOut">
               <a:rPr lang="en-US" smtClean="0"/>
-              <a:t>4/9/2025</a:t>
+              <a:t>3/15/2026</a:t>
             </a:fld>
             <a:endParaRPr lang="en-US"/>
           </a:p>
@@ -2090,7 +2530,7 @@
           <a:p>
             <a:fld id="{A1C33FE8-8021-45D4-B0C5-0B5FC73F013B}" type="datetimeFigureOut">
               <a:rPr lang="en-US" smtClean="0"/>
-              <a:t>4/9/2025</a:t>
+              <a:t>3/15/2026</a:t>
             </a:fld>
             <a:endParaRPr lang="en-US"/>
           </a:p>
@@ -2355,7 +2795,7 @@
           <a:p>
             <a:fld id="{A1C33FE8-8021-45D4-B0C5-0B5FC73F013B}" type="datetimeFigureOut">
               <a:rPr lang="en-US" smtClean="0"/>
-              <a:t>4/9/2025</a:t>
+              <a:t>3/15/2026</a:t>
             </a:fld>
             <a:endParaRPr lang="en-US"/>
           </a:p>
@@ -2767,7 +3207,7 @@
           <a:p>
             <a:fld id="{A1C33FE8-8021-45D4-B0C5-0B5FC73F013B}" type="datetimeFigureOut">
               <a:rPr lang="en-US" smtClean="0"/>
-              <a:t>4/9/2025</a:t>
+              <a:t>3/15/2026</a:t>
             </a:fld>
             <a:endParaRPr lang="en-US"/>
           </a:p>
@@ -2908,7 +3348,7 @@
           <a:p>
             <a:fld id="{A1C33FE8-8021-45D4-B0C5-0B5FC73F013B}" type="datetimeFigureOut">
               <a:rPr lang="en-US" smtClean="0"/>
-              <a:t>4/9/2025</a:t>
+              <a:t>3/15/2026</a:t>
             </a:fld>
             <a:endParaRPr lang="en-US"/>
           </a:p>
@@ -3021,7 +3461,7 @@
           <a:p>
             <a:fld id="{A1C33FE8-8021-45D4-B0C5-0B5FC73F013B}" type="datetimeFigureOut">
               <a:rPr lang="en-US" smtClean="0"/>
-              <a:t>4/9/2025</a:t>
+              <a:t>3/15/2026</a:t>
             </a:fld>
             <a:endParaRPr lang="en-US"/>
           </a:p>
@@ -3332,7 +3772,7 @@
           <a:p>
             <a:fld id="{A1C33FE8-8021-45D4-B0C5-0B5FC73F013B}" type="datetimeFigureOut">
               <a:rPr lang="en-US" smtClean="0"/>
-              <a:t>4/9/2025</a:t>
+              <a:t>3/15/2026</a:t>
             </a:fld>
             <a:endParaRPr lang="en-US"/>
           </a:p>
@@ -3620,7 +4060,7 @@
           <a:p>
             <a:fld id="{A1C33FE8-8021-45D4-B0C5-0B5FC73F013B}" type="datetimeFigureOut">
               <a:rPr lang="en-US" smtClean="0"/>
-              <a:t>4/9/2025</a:t>
+              <a:t>3/15/2026</a:t>
             </a:fld>
             <a:endParaRPr lang="en-US"/>
           </a:p>
@@ -3861,7 +4301,7 @@
           <a:p>
             <a:fld id="{A1C33FE8-8021-45D4-B0C5-0B5FC73F013B}" type="datetimeFigureOut">
               <a:rPr lang="en-US" smtClean="0"/>
-              <a:t>4/9/2025</a:t>
+              <a:t>3/15/2026</a:t>
             </a:fld>
             <a:endParaRPr lang="en-US"/>
           </a:p>
@@ -4345,6 +4785,1161 @@
 </p:sld>
 </file>
 
+<file path=ppt/slides/slide10.xml><?xml version="1.0" encoding="utf-8"?>
+<p:sld xmlns:a="http://schemas.openxmlformats.org/drawingml/2006/main" xmlns:r="http://schemas.openxmlformats.org/officeDocument/2006/relationships" xmlns:p="http://schemas.openxmlformats.org/presentationml/2006/main">
+  <p:cSld>
+    <p:spTree>
+      <p:nvGrpSpPr>
+        <p:cNvPr id="1" name="">
+          <a:extLst>
+            <a:ext uri="{FF2B5EF4-FFF2-40B4-BE49-F238E27FC236}">
+              <a16:creationId xmlns:a16="http://schemas.microsoft.com/office/drawing/2014/main" id="{E4A28581-D61C-6157-B4F7-DCC97980BDDE}"/>
+            </a:ext>
+          </a:extLst>
+        </p:cNvPr>
+        <p:cNvGrpSpPr/>
+        <p:nvPr/>
+      </p:nvGrpSpPr>
+      <p:grpSpPr>
+        <a:xfrm>
+          <a:off x="0" y="0"/>
+          <a:ext cx="0" cy="0"/>
+          <a:chOff x="0" y="0"/>
+          <a:chExt cx="0" cy="0"/>
+        </a:xfrm>
+      </p:grpSpPr>
+      <p:sp>
+        <p:nvSpPr>
+          <p:cNvPr id="2" name="Title 1">
+            <a:extLst>
+              <a:ext uri="{FF2B5EF4-FFF2-40B4-BE49-F238E27FC236}">
+                <a16:creationId xmlns:a16="http://schemas.microsoft.com/office/drawing/2014/main" id="{351D282B-6F1E-76B4-5134-6FBECD4E48A6}"/>
+              </a:ext>
+            </a:extLst>
+          </p:cNvPr>
+          <p:cNvSpPr>
+            <a:spLocks noGrp="1"/>
+          </p:cNvSpPr>
+          <p:nvPr>
+            <p:ph type="title"/>
+          </p:nvPr>
+        </p:nvSpPr>
+        <p:spPr/>
+        <p:txBody>
+          <a:bodyPr/>
+          <a:lstStyle/>
+          <a:p>
+            <a:r>
+              <a:rPr lang="en-US" dirty="0"/>
+              <a:t>Exchange Scenarios</a:t>
+            </a:r>
+          </a:p>
+        </p:txBody>
+      </p:sp>
+      <p:pic>
+        <p:nvPicPr>
+          <p:cNvPr id="1026" name="Picture 2" descr="Hospital buildings - Free medical icons">
+            <a:extLst>
+              <a:ext uri="{FF2B5EF4-FFF2-40B4-BE49-F238E27FC236}">
+                <a16:creationId xmlns:a16="http://schemas.microsoft.com/office/drawing/2014/main" id="{48E531DA-1D7D-B81B-112E-614B2410090C}"/>
+              </a:ext>
+            </a:extLst>
+          </p:cNvPr>
+          <p:cNvPicPr>
+            <a:picLocks noChangeAspect="1" noChangeArrowheads="1"/>
+          </p:cNvPicPr>
+          <p:nvPr/>
+        </p:nvPicPr>
+        <p:blipFill>
+          <a:blip r:embed="rId2">
+            <a:extLst>
+              <a:ext uri="{28A0092B-C50C-407E-A947-70E740481C1C}">
+                <a14:useLocalDpi xmlns:a14="http://schemas.microsoft.com/office/drawing/2010/main" val="0"/>
+              </a:ext>
+            </a:extLst>
+          </a:blip>
+          <a:srcRect/>
+          <a:stretch>
+            <a:fillRect/>
+          </a:stretch>
+        </p:blipFill>
+        <p:spPr bwMode="auto">
+          <a:xfrm flipH="1">
+            <a:off x="3029777" y="2934990"/>
+            <a:ext cx="771282" cy="771282"/>
+          </a:xfrm>
+          <a:prstGeom prst="rect">
+            <a:avLst/>
+          </a:prstGeom>
+          <a:noFill/>
+          <a:extLst>
+            <a:ext uri="{909E8E84-426E-40DD-AFC4-6F175D3DCCD1}">
+              <a14:hiddenFill xmlns:a14="http://schemas.microsoft.com/office/drawing/2010/main">
+                <a:solidFill>
+                  <a:srgbClr val="FFFFFF"/>
+                </a:solidFill>
+              </a14:hiddenFill>
+            </a:ext>
+          </a:extLst>
+        </p:spPr>
+      </p:pic>
+      <p:pic>
+        <p:nvPicPr>
+          <p:cNvPr id="1028" name="Picture 4" descr="Clinic Icons - Free SVG &amp; PNG Clinic Images - Noun Project">
+            <a:extLst>
+              <a:ext uri="{FF2B5EF4-FFF2-40B4-BE49-F238E27FC236}">
+                <a16:creationId xmlns:a16="http://schemas.microsoft.com/office/drawing/2014/main" id="{7E8EB0E6-F24A-DD41-2C2E-84D4E4E1E616}"/>
+              </a:ext>
+            </a:extLst>
+          </p:cNvPr>
+          <p:cNvPicPr>
+            <a:picLocks noChangeAspect="1" noChangeArrowheads="1"/>
+          </p:cNvPicPr>
+          <p:nvPr/>
+        </p:nvPicPr>
+        <p:blipFill>
+          <a:blip r:embed="rId3">
+            <a:extLst>
+              <a:ext uri="{28A0092B-C50C-407E-A947-70E740481C1C}">
+                <a14:useLocalDpi xmlns:a14="http://schemas.microsoft.com/office/drawing/2010/main" val="0"/>
+              </a:ext>
+            </a:extLst>
+          </a:blip>
+          <a:srcRect/>
+          <a:stretch>
+            <a:fillRect/>
+          </a:stretch>
+        </p:blipFill>
+        <p:spPr bwMode="auto">
+          <a:xfrm>
+            <a:off x="3029777" y="3706272"/>
+            <a:ext cx="771282" cy="771282"/>
+          </a:xfrm>
+          <a:prstGeom prst="rect">
+            <a:avLst/>
+          </a:prstGeom>
+          <a:noFill/>
+          <a:extLst>
+            <a:ext uri="{909E8E84-426E-40DD-AFC4-6F175D3DCCD1}">
+              <a14:hiddenFill xmlns:a14="http://schemas.microsoft.com/office/drawing/2010/main">
+                <a:solidFill>
+                  <a:srgbClr val="FFFFFF"/>
+                </a:solidFill>
+              </a14:hiddenFill>
+            </a:ext>
+          </a:extLst>
+        </p:spPr>
+      </p:pic>
+      <p:pic>
+        <p:nvPicPr>
+          <p:cNvPr id="1034" name="Picture 10" descr="Engine Gears Icon SVG Vector &amp; PNG Free Download | UXWing">
+            <a:extLst>
+              <a:ext uri="{FF2B5EF4-FFF2-40B4-BE49-F238E27FC236}">
+                <a16:creationId xmlns:a16="http://schemas.microsoft.com/office/drawing/2014/main" id="{2D4A0E15-17CB-C115-6410-C7858E147668}"/>
+              </a:ext>
+            </a:extLst>
+          </p:cNvPr>
+          <p:cNvPicPr>
+            <a:picLocks noChangeAspect="1" noChangeArrowheads="1"/>
+          </p:cNvPicPr>
+          <p:nvPr/>
+        </p:nvPicPr>
+        <p:blipFill>
+          <a:blip r:embed="rId4">
+            <a:extLst>
+              <a:ext uri="{28A0092B-C50C-407E-A947-70E740481C1C}">
+                <a14:useLocalDpi xmlns:a14="http://schemas.microsoft.com/office/drawing/2010/main" val="0"/>
+              </a:ext>
+            </a:extLst>
+          </a:blip>
+          <a:srcRect/>
+          <a:stretch>
+            <a:fillRect/>
+          </a:stretch>
+        </p:blipFill>
+        <p:spPr bwMode="auto">
+          <a:xfrm>
+            <a:off x="5710360" y="3172347"/>
+            <a:ext cx="771282" cy="873632"/>
+          </a:xfrm>
+          <a:prstGeom prst="rect">
+            <a:avLst/>
+          </a:prstGeom>
+          <a:noFill/>
+          <a:extLst>
+            <a:ext uri="{909E8E84-426E-40DD-AFC4-6F175D3DCCD1}">
+              <a14:hiddenFill xmlns:a14="http://schemas.microsoft.com/office/drawing/2010/main">
+                <a:solidFill>
+                  <a:srgbClr val="FFFFFF"/>
+                </a:solidFill>
+              </a14:hiddenFill>
+            </a:ext>
+          </a:extLst>
+        </p:spPr>
+      </p:pic>
+      <p:pic>
+        <p:nvPicPr>
+          <p:cNvPr id="1040" name="Picture 16" descr="Documents symbol - Free interface icons">
+            <a:extLst>
+              <a:ext uri="{FF2B5EF4-FFF2-40B4-BE49-F238E27FC236}">
+                <a16:creationId xmlns:a16="http://schemas.microsoft.com/office/drawing/2014/main" id="{C39B551F-663C-47DB-D0C4-043A91F03122}"/>
+              </a:ext>
+            </a:extLst>
+          </p:cNvPr>
+          <p:cNvPicPr>
+            <a:picLocks noChangeAspect="1" noChangeArrowheads="1"/>
+          </p:cNvPicPr>
+          <p:nvPr/>
+        </p:nvPicPr>
+        <p:blipFill>
+          <a:blip r:embed="rId5">
+            <a:extLst>
+              <a:ext uri="{28A0092B-C50C-407E-A947-70E740481C1C}">
+                <a14:useLocalDpi xmlns:a14="http://schemas.microsoft.com/office/drawing/2010/main" val="0"/>
+              </a:ext>
+            </a:extLst>
+          </a:blip>
+          <a:srcRect/>
+          <a:stretch>
+            <a:fillRect/>
+          </a:stretch>
+        </p:blipFill>
+        <p:spPr bwMode="auto">
+          <a:xfrm>
+            <a:off x="4450197" y="3493546"/>
+            <a:ext cx="418204" cy="418204"/>
+          </a:xfrm>
+          <a:prstGeom prst="rect">
+            <a:avLst/>
+          </a:prstGeom>
+          <a:noFill/>
+          <a:extLst>
+            <a:ext uri="{909E8E84-426E-40DD-AFC4-6F175D3DCCD1}">
+              <a14:hiddenFill xmlns:a14="http://schemas.microsoft.com/office/drawing/2010/main">
+                <a:solidFill>
+                  <a:srgbClr val="FFFFFF"/>
+                </a:solidFill>
+              </a14:hiddenFill>
+            </a:ext>
+          </a:extLst>
+        </p:spPr>
+      </p:pic>
+      <p:pic>
+        <p:nvPicPr>
+          <p:cNvPr id="1042" name="Picture 18" descr="Database Icons - Free SVG &amp; PNG Database Images - Noun Project">
+            <a:extLst>
+              <a:ext uri="{FF2B5EF4-FFF2-40B4-BE49-F238E27FC236}">
+                <a16:creationId xmlns:a16="http://schemas.microsoft.com/office/drawing/2014/main" id="{1211FF00-CF7D-5E84-013A-F5AD046C63BD}"/>
+              </a:ext>
+            </a:extLst>
+          </p:cNvPr>
+          <p:cNvPicPr>
+            <a:picLocks noChangeAspect="1" noChangeArrowheads="1"/>
+          </p:cNvPicPr>
+          <p:nvPr/>
+        </p:nvPicPr>
+        <p:blipFill>
+          <a:blip r:embed="rId6">
+            <a:extLst>
+              <a:ext uri="{28A0092B-C50C-407E-A947-70E740481C1C}">
+                <a14:useLocalDpi xmlns:a14="http://schemas.microsoft.com/office/drawing/2010/main" val="0"/>
+              </a:ext>
+            </a:extLst>
+          </a:blip>
+          <a:srcRect/>
+          <a:stretch>
+            <a:fillRect/>
+          </a:stretch>
+        </p:blipFill>
+        <p:spPr bwMode="auto">
+          <a:xfrm>
+            <a:off x="5324718" y="3429000"/>
+            <a:ext cx="771282" cy="771282"/>
+          </a:xfrm>
+          <a:prstGeom prst="rect">
+            <a:avLst/>
+          </a:prstGeom>
+          <a:noFill/>
+          <a:extLst>
+            <a:ext uri="{909E8E84-426E-40DD-AFC4-6F175D3DCCD1}">
+              <a14:hiddenFill xmlns:a14="http://schemas.microsoft.com/office/drawing/2010/main">
+                <a:solidFill>
+                  <a:srgbClr val="FFFFFF"/>
+                </a:solidFill>
+              </a14:hiddenFill>
+            </a:ext>
+          </a:extLst>
+        </p:spPr>
+      </p:pic>
+      <p:sp>
+        <p:nvSpPr>
+          <p:cNvPr id="5" name="TextBox 4">
+            <a:extLst>
+              <a:ext uri="{FF2B5EF4-FFF2-40B4-BE49-F238E27FC236}">
+                <a16:creationId xmlns:a16="http://schemas.microsoft.com/office/drawing/2014/main" id="{008ACC95-A401-E668-12B1-1C7974A3C764}"/>
+              </a:ext>
+            </a:extLst>
+          </p:cNvPr>
+          <p:cNvSpPr txBox="1"/>
+          <p:nvPr/>
+        </p:nvSpPr>
+        <p:spPr>
+          <a:xfrm>
+            <a:off x="2885786" y="2375177"/>
+            <a:ext cx="1059264" cy="369332"/>
+          </a:xfrm>
+          <a:prstGeom prst="rect">
+            <a:avLst/>
+          </a:prstGeom>
+          <a:noFill/>
+        </p:spPr>
+        <p:txBody>
+          <a:bodyPr wrap="none" rtlCol="0">
+            <a:spAutoFit/>
+          </a:bodyPr>
+          <a:lstStyle/>
+          <a:p>
+            <a:pPr algn="ctr"/>
+            <a:r>
+              <a:rPr lang="en-US" b="1" dirty="0"/>
+              <a:t>Provider</a:t>
+            </a:r>
+          </a:p>
+        </p:txBody>
+      </p:sp>
+      <p:sp>
+        <p:nvSpPr>
+          <p:cNvPr id="6" name="TextBox 5">
+            <a:extLst>
+              <a:ext uri="{FF2B5EF4-FFF2-40B4-BE49-F238E27FC236}">
+                <a16:creationId xmlns:a16="http://schemas.microsoft.com/office/drawing/2014/main" id="{2F650C80-6D41-9930-9883-7B2729D45804}"/>
+              </a:ext>
+            </a:extLst>
+          </p:cNvPr>
+          <p:cNvSpPr txBox="1"/>
+          <p:nvPr/>
+        </p:nvSpPr>
+        <p:spPr>
+          <a:xfrm>
+            <a:off x="5059901" y="2236677"/>
+            <a:ext cx="1300915" cy="646331"/>
+          </a:xfrm>
+          <a:prstGeom prst="rect">
+            <a:avLst/>
+          </a:prstGeom>
+          <a:noFill/>
+        </p:spPr>
+        <p:txBody>
+          <a:bodyPr wrap="square" rtlCol="0">
+            <a:spAutoFit/>
+          </a:bodyPr>
+          <a:lstStyle/>
+          <a:p>
+            <a:pPr algn="ctr"/>
+            <a:r>
+              <a:rPr lang="en-US" b="1" dirty="0"/>
+              <a:t>Reporting System</a:t>
+            </a:r>
+          </a:p>
+        </p:txBody>
+      </p:sp>
+      <p:sp>
+        <p:nvSpPr>
+          <p:cNvPr id="8" name="Left Brace 7">
+            <a:extLst>
+              <a:ext uri="{FF2B5EF4-FFF2-40B4-BE49-F238E27FC236}">
+                <a16:creationId xmlns:a16="http://schemas.microsoft.com/office/drawing/2014/main" id="{297BDB8B-84BE-C44D-DB7D-8C8C5D620BEF}"/>
+              </a:ext>
+            </a:extLst>
+          </p:cNvPr>
+          <p:cNvSpPr/>
+          <p:nvPr/>
+        </p:nvSpPr>
+        <p:spPr>
+          <a:xfrm rot="16200000">
+            <a:off x="4408212" y="3690240"/>
+            <a:ext cx="397372" cy="2382955"/>
+          </a:xfrm>
+          <a:prstGeom prst="leftBrace">
+            <a:avLst>
+              <a:gd name="adj1" fmla="val 57063"/>
+              <a:gd name="adj2" fmla="val 50000"/>
+            </a:avLst>
+          </a:prstGeom>
+          <a:ln w="38100"/>
+        </p:spPr>
+        <p:style>
+          <a:lnRef idx="3">
+            <a:schemeClr val="dk1"/>
+          </a:lnRef>
+          <a:fillRef idx="0">
+            <a:schemeClr val="dk1"/>
+          </a:fillRef>
+          <a:effectRef idx="2">
+            <a:schemeClr val="dk1"/>
+          </a:effectRef>
+          <a:fontRef idx="minor">
+            <a:schemeClr val="tx1"/>
+          </a:fontRef>
+        </p:style>
+        <p:txBody>
+          <a:bodyPr rtlCol="0" anchor="ctr"/>
+          <a:lstStyle/>
+          <a:p>
+            <a:pPr algn="ctr"/>
+            <a:endParaRPr lang="en-US"/>
+          </a:p>
+        </p:txBody>
+      </p:sp>
+      <p:sp>
+        <p:nvSpPr>
+          <p:cNvPr id="10" name="TextBox 9">
+            <a:extLst>
+              <a:ext uri="{FF2B5EF4-FFF2-40B4-BE49-F238E27FC236}">
+                <a16:creationId xmlns:a16="http://schemas.microsoft.com/office/drawing/2014/main" id="{C8707268-647A-FB39-9CF8-E7C7D5B1D545}"/>
+              </a:ext>
+            </a:extLst>
+          </p:cNvPr>
+          <p:cNvSpPr txBox="1"/>
+          <p:nvPr/>
+        </p:nvSpPr>
+        <p:spPr>
+          <a:xfrm>
+            <a:off x="4011576" y="5193821"/>
+            <a:ext cx="1190647" cy="369332"/>
+          </a:xfrm>
+          <a:prstGeom prst="rect">
+            <a:avLst/>
+          </a:prstGeom>
+          <a:noFill/>
+        </p:spPr>
+        <p:txBody>
+          <a:bodyPr wrap="none" rtlCol="0">
+            <a:spAutoFit/>
+          </a:bodyPr>
+          <a:lstStyle/>
+          <a:p>
+            <a:pPr algn="ctr"/>
+            <a:r>
+              <a:rPr lang="en-US" b="1" dirty="0"/>
+              <a:t>Exchange</a:t>
+            </a:r>
+          </a:p>
+        </p:txBody>
+      </p:sp>
+      <p:sp>
+        <p:nvSpPr>
+          <p:cNvPr id="3" name="Content Placeholder 3">
+            <a:extLst>
+              <a:ext uri="{FF2B5EF4-FFF2-40B4-BE49-F238E27FC236}">
+                <a16:creationId xmlns:a16="http://schemas.microsoft.com/office/drawing/2014/main" id="{74CE161D-EFB5-4D38-FC5C-E841E8F00892}"/>
+              </a:ext>
+            </a:extLst>
+          </p:cNvPr>
+          <p:cNvSpPr txBox="1">
+            <a:spLocks/>
+          </p:cNvSpPr>
+          <p:nvPr/>
+        </p:nvSpPr>
+        <p:spPr>
+          <a:xfrm>
+            <a:off x="6989779" y="3285949"/>
+            <a:ext cx="4364021" cy="1057383"/>
+          </a:xfrm>
+          <a:prstGeom prst="rect">
+            <a:avLst/>
+          </a:prstGeom>
+        </p:spPr>
+        <p:txBody>
+          <a:bodyPr/>
+          <a:lstStyle>
+            <a:lvl1pPr marL="228600" indent="-228600" algn="l" defTabSz="914400" rtl="0" eaLnBrk="1" latinLnBrk="0" hangingPunct="1">
+              <a:lnSpc>
+                <a:spcPct val="90000"/>
+              </a:lnSpc>
+              <a:spcBef>
+                <a:spcPts val="1000"/>
+              </a:spcBef>
+              <a:buFont typeface="Arial" panose="020B0604020202020204" pitchFamily="34" charset="0"/>
+              <a:buChar char="•"/>
+              <a:defRPr sz="2800" kern="1200">
+                <a:solidFill>
+                  <a:schemeClr val="tx1"/>
+                </a:solidFill>
+                <a:latin typeface="+mn-lt"/>
+                <a:ea typeface="+mn-ea"/>
+                <a:cs typeface="+mn-cs"/>
+              </a:defRPr>
+            </a:lvl1pPr>
+            <a:lvl2pPr marL="685800" indent="-228600" algn="l" defTabSz="914400" rtl="0" eaLnBrk="1" latinLnBrk="0" hangingPunct="1">
+              <a:lnSpc>
+                <a:spcPct val="90000"/>
+              </a:lnSpc>
+              <a:spcBef>
+                <a:spcPts val="500"/>
+              </a:spcBef>
+              <a:buFont typeface="Arial" panose="020B0604020202020204" pitchFamily="34" charset="0"/>
+              <a:buChar char="•"/>
+              <a:defRPr sz="2400" kern="1200">
+                <a:solidFill>
+                  <a:schemeClr val="tx1"/>
+                </a:solidFill>
+                <a:latin typeface="+mn-lt"/>
+                <a:ea typeface="+mn-ea"/>
+                <a:cs typeface="+mn-cs"/>
+              </a:defRPr>
+            </a:lvl2pPr>
+            <a:lvl3pPr marL="1143000" indent="-228600" algn="l" defTabSz="914400" rtl="0" eaLnBrk="1" latinLnBrk="0" hangingPunct="1">
+              <a:lnSpc>
+                <a:spcPct val="90000"/>
+              </a:lnSpc>
+              <a:spcBef>
+                <a:spcPts val="500"/>
+              </a:spcBef>
+              <a:buFont typeface="Arial" panose="020B0604020202020204" pitchFamily="34" charset="0"/>
+              <a:buChar char="•"/>
+              <a:defRPr sz="2000" kern="1200">
+                <a:solidFill>
+                  <a:schemeClr val="tx1"/>
+                </a:solidFill>
+                <a:latin typeface="+mn-lt"/>
+                <a:ea typeface="+mn-ea"/>
+                <a:cs typeface="+mn-cs"/>
+              </a:defRPr>
+            </a:lvl3pPr>
+            <a:lvl4pPr marL="1600200" indent="-228600" algn="l" defTabSz="914400" rtl="0" eaLnBrk="1" latinLnBrk="0" hangingPunct="1">
+              <a:lnSpc>
+                <a:spcPct val="90000"/>
+              </a:lnSpc>
+              <a:spcBef>
+                <a:spcPts val="500"/>
+              </a:spcBef>
+              <a:buFont typeface="Arial" panose="020B0604020202020204" pitchFamily="34" charset="0"/>
+              <a:buChar char="•"/>
+              <a:defRPr sz="1800" kern="1200">
+                <a:solidFill>
+                  <a:schemeClr val="tx1"/>
+                </a:solidFill>
+                <a:latin typeface="+mn-lt"/>
+                <a:ea typeface="+mn-ea"/>
+                <a:cs typeface="+mn-cs"/>
+              </a:defRPr>
+            </a:lvl4pPr>
+            <a:lvl5pPr marL="2057400" indent="-228600" algn="l" defTabSz="914400" rtl="0" eaLnBrk="1" latinLnBrk="0" hangingPunct="1">
+              <a:lnSpc>
+                <a:spcPct val="90000"/>
+              </a:lnSpc>
+              <a:spcBef>
+                <a:spcPts val="500"/>
+              </a:spcBef>
+              <a:buFont typeface="Arial" panose="020B0604020202020204" pitchFamily="34" charset="0"/>
+              <a:buChar char="•"/>
+              <a:defRPr sz="1800" kern="1200">
+                <a:solidFill>
+                  <a:schemeClr val="tx1"/>
+                </a:solidFill>
+                <a:latin typeface="+mn-lt"/>
+                <a:ea typeface="+mn-ea"/>
+                <a:cs typeface="+mn-cs"/>
+              </a:defRPr>
+            </a:lvl5pPr>
+            <a:lvl6pPr marL="2514600" indent="-228600" algn="l" defTabSz="914400" rtl="0" eaLnBrk="1" latinLnBrk="0" hangingPunct="1">
+              <a:lnSpc>
+                <a:spcPct val="90000"/>
+              </a:lnSpc>
+              <a:spcBef>
+                <a:spcPts val="500"/>
+              </a:spcBef>
+              <a:buFont typeface="Arial" panose="020B0604020202020204" pitchFamily="34" charset="0"/>
+              <a:buChar char="•"/>
+              <a:defRPr sz="1800" kern="1200">
+                <a:solidFill>
+                  <a:schemeClr val="tx1"/>
+                </a:solidFill>
+                <a:latin typeface="+mn-lt"/>
+                <a:ea typeface="+mn-ea"/>
+                <a:cs typeface="+mn-cs"/>
+              </a:defRPr>
+            </a:lvl6pPr>
+            <a:lvl7pPr marL="2971800" indent="-228600" algn="l" defTabSz="914400" rtl="0" eaLnBrk="1" latinLnBrk="0" hangingPunct="1">
+              <a:lnSpc>
+                <a:spcPct val="90000"/>
+              </a:lnSpc>
+              <a:spcBef>
+                <a:spcPts val="500"/>
+              </a:spcBef>
+              <a:buFont typeface="Arial" panose="020B0604020202020204" pitchFamily="34" charset="0"/>
+              <a:buChar char="•"/>
+              <a:defRPr sz="1800" kern="1200">
+                <a:solidFill>
+                  <a:schemeClr val="tx1"/>
+                </a:solidFill>
+                <a:latin typeface="+mn-lt"/>
+                <a:ea typeface="+mn-ea"/>
+                <a:cs typeface="+mn-cs"/>
+              </a:defRPr>
+            </a:lvl7pPr>
+            <a:lvl8pPr marL="3429000" indent="-228600" algn="l" defTabSz="914400" rtl="0" eaLnBrk="1" latinLnBrk="0" hangingPunct="1">
+              <a:lnSpc>
+                <a:spcPct val="90000"/>
+              </a:lnSpc>
+              <a:spcBef>
+                <a:spcPts val="500"/>
+              </a:spcBef>
+              <a:buFont typeface="Arial" panose="020B0604020202020204" pitchFamily="34" charset="0"/>
+              <a:buChar char="•"/>
+              <a:defRPr sz="1800" kern="1200">
+                <a:solidFill>
+                  <a:schemeClr val="tx1"/>
+                </a:solidFill>
+                <a:latin typeface="+mn-lt"/>
+                <a:ea typeface="+mn-ea"/>
+                <a:cs typeface="+mn-cs"/>
+              </a:defRPr>
+            </a:lvl8pPr>
+            <a:lvl9pPr marL="3886200" indent="-228600" algn="l" defTabSz="914400" rtl="0" eaLnBrk="1" latinLnBrk="0" hangingPunct="1">
+              <a:lnSpc>
+                <a:spcPct val="90000"/>
+              </a:lnSpc>
+              <a:spcBef>
+                <a:spcPts val="500"/>
+              </a:spcBef>
+              <a:buFont typeface="Arial" panose="020B0604020202020204" pitchFamily="34" charset="0"/>
+              <a:buChar char="•"/>
+              <a:defRPr sz="1800" kern="1200">
+                <a:solidFill>
+                  <a:schemeClr val="tx1"/>
+                </a:solidFill>
+                <a:latin typeface="+mn-lt"/>
+                <a:ea typeface="+mn-ea"/>
+                <a:cs typeface="+mn-cs"/>
+              </a:defRPr>
+            </a:lvl9pPr>
+          </a:lstStyle>
+          <a:p>
+            <a:pPr marL="514350" indent="-514350">
+              <a:buFont typeface="Arial" panose="020B0604020202020204" pitchFamily="34" charset="0"/>
+              <a:buAutoNum type="arabicPeriod"/>
+            </a:pPr>
+            <a:r>
+              <a:rPr lang="en-US" dirty="0"/>
+              <a:t>Push (Submit), or</a:t>
+            </a:r>
+          </a:p>
+          <a:p>
+            <a:pPr marL="514350" indent="-514350">
+              <a:buFont typeface="Arial" panose="020B0604020202020204" pitchFamily="34" charset="0"/>
+              <a:buAutoNum type="arabicPeriod"/>
+            </a:pPr>
+            <a:r>
+              <a:rPr lang="en-US" dirty="0"/>
+              <a:t>Pull (Collect)</a:t>
+            </a:r>
+          </a:p>
+        </p:txBody>
+      </p:sp>
+    </p:spTree>
+    <p:extLst>
+      <p:ext uri="{BB962C8B-B14F-4D97-AF65-F5344CB8AC3E}">
+        <p14:creationId xmlns:p14="http://schemas.microsoft.com/office/powerpoint/2010/main" val="4249664613"/>
+      </p:ext>
+    </p:extLst>
+  </p:cSld>
+  <p:clrMapOvr>
+    <a:masterClrMapping/>
+  </p:clrMapOvr>
+</p:sld>
+</file>
+
+<file path=ppt/slides/slide11.xml><?xml version="1.0" encoding="utf-8"?>
+<p:sld xmlns:a="http://schemas.openxmlformats.org/drawingml/2006/main" xmlns:r="http://schemas.openxmlformats.org/officeDocument/2006/relationships" xmlns:p="http://schemas.openxmlformats.org/presentationml/2006/main">
+  <p:cSld>
+    <p:spTree>
+      <p:nvGrpSpPr>
+        <p:cNvPr id="1" name="">
+          <a:extLst>
+            <a:ext uri="{FF2B5EF4-FFF2-40B4-BE49-F238E27FC236}">
+              <a16:creationId xmlns:a16="http://schemas.microsoft.com/office/drawing/2014/main" id="{5391A2D4-7F98-F545-240B-E68DB70C2003}"/>
+            </a:ext>
+          </a:extLst>
+        </p:cNvPr>
+        <p:cNvGrpSpPr/>
+        <p:nvPr/>
+      </p:nvGrpSpPr>
+      <p:grpSpPr>
+        <a:xfrm>
+          <a:off x="0" y="0"/>
+          <a:ext cx="0" cy="0"/>
+          <a:chOff x="0" y="0"/>
+          <a:chExt cx="0" cy="0"/>
+        </a:xfrm>
+      </p:grpSpPr>
+      <p:sp>
+        <p:nvSpPr>
+          <p:cNvPr id="2" name="Title 1">
+            <a:extLst>
+              <a:ext uri="{FF2B5EF4-FFF2-40B4-BE49-F238E27FC236}">
+                <a16:creationId xmlns:a16="http://schemas.microsoft.com/office/drawing/2014/main" id="{DD6AC4A7-1981-FED3-6564-B71D954F2415}"/>
+              </a:ext>
+            </a:extLst>
+          </p:cNvPr>
+          <p:cNvSpPr>
+            <a:spLocks noGrp="1"/>
+          </p:cNvSpPr>
+          <p:nvPr>
+            <p:ph type="title"/>
+          </p:nvPr>
+        </p:nvSpPr>
+        <p:spPr/>
+        <p:txBody>
+          <a:bodyPr/>
+          <a:lstStyle/>
+          <a:p>
+            <a:r>
+              <a:rPr lang="en-US" dirty="0"/>
+              <a:t>Reporting Scenarios</a:t>
+            </a:r>
+          </a:p>
+        </p:txBody>
+      </p:sp>
+      <p:pic>
+        <p:nvPicPr>
+          <p:cNvPr id="1032" name="Picture 8" descr="Monthly Report Icons - Free SVG &amp; PNG Monthly Report Images ...">
+            <a:extLst>
+              <a:ext uri="{FF2B5EF4-FFF2-40B4-BE49-F238E27FC236}">
+                <a16:creationId xmlns:a16="http://schemas.microsoft.com/office/drawing/2014/main" id="{D6A2B16B-6EAC-8022-F09C-BD8A6BE04731}"/>
+              </a:ext>
+            </a:extLst>
+          </p:cNvPr>
+          <p:cNvPicPr>
+            <a:picLocks noChangeAspect="1" noChangeArrowheads="1"/>
+          </p:cNvPicPr>
+          <p:nvPr/>
+        </p:nvPicPr>
+        <p:blipFill>
+          <a:blip r:embed="rId2">
+            <a:extLst>
+              <a:ext uri="{28A0092B-C50C-407E-A947-70E740481C1C}">
+                <a14:useLocalDpi xmlns:a14="http://schemas.microsoft.com/office/drawing/2010/main" val="0"/>
+              </a:ext>
+            </a:extLst>
+          </a:blip>
+          <a:srcRect/>
+          <a:stretch>
+            <a:fillRect/>
+          </a:stretch>
+        </p:blipFill>
+        <p:spPr bwMode="auto">
+          <a:xfrm>
+            <a:off x="6937960" y="3493546"/>
+            <a:ext cx="418204" cy="418204"/>
+          </a:xfrm>
+          <a:prstGeom prst="rect">
+            <a:avLst/>
+          </a:prstGeom>
+          <a:noFill/>
+          <a:extLst>
+            <a:ext uri="{909E8E84-426E-40DD-AFC4-6F175D3DCCD1}">
+              <a14:hiddenFill xmlns:a14="http://schemas.microsoft.com/office/drawing/2010/main">
+                <a:solidFill>
+                  <a:srgbClr val="FFFFFF"/>
+                </a:solidFill>
+              </a14:hiddenFill>
+            </a:ext>
+          </a:extLst>
+        </p:spPr>
+      </p:pic>
+      <p:pic>
+        <p:nvPicPr>
+          <p:cNvPr id="1034" name="Picture 10" descr="Engine Gears Icon SVG Vector &amp; PNG Free Download | UXWing">
+            <a:extLst>
+              <a:ext uri="{FF2B5EF4-FFF2-40B4-BE49-F238E27FC236}">
+                <a16:creationId xmlns:a16="http://schemas.microsoft.com/office/drawing/2014/main" id="{936F6A86-F3A0-9BE6-693D-CFB1390963D7}"/>
+              </a:ext>
+            </a:extLst>
+          </p:cNvPr>
+          <p:cNvPicPr>
+            <a:picLocks noChangeAspect="1" noChangeArrowheads="1"/>
+          </p:cNvPicPr>
+          <p:nvPr/>
+        </p:nvPicPr>
+        <p:blipFill>
+          <a:blip r:embed="rId3">
+            <a:extLst>
+              <a:ext uri="{28A0092B-C50C-407E-A947-70E740481C1C}">
+                <a14:useLocalDpi xmlns:a14="http://schemas.microsoft.com/office/drawing/2010/main" val="0"/>
+              </a:ext>
+            </a:extLst>
+          </a:blip>
+          <a:srcRect/>
+          <a:stretch>
+            <a:fillRect/>
+          </a:stretch>
+        </p:blipFill>
+        <p:spPr bwMode="auto">
+          <a:xfrm>
+            <a:off x="5710360" y="3172347"/>
+            <a:ext cx="771282" cy="873632"/>
+          </a:xfrm>
+          <a:prstGeom prst="rect">
+            <a:avLst/>
+          </a:prstGeom>
+          <a:noFill/>
+          <a:extLst>
+            <a:ext uri="{909E8E84-426E-40DD-AFC4-6F175D3DCCD1}">
+              <a14:hiddenFill xmlns:a14="http://schemas.microsoft.com/office/drawing/2010/main">
+                <a:solidFill>
+                  <a:srgbClr val="FFFFFF"/>
+                </a:solidFill>
+              </a14:hiddenFill>
+            </a:ext>
+          </a:extLst>
+        </p:spPr>
+      </p:pic>
+      <p:pic>
+        <p:nvPicPr>
+          <p:cNvPr id="1038" name="Picture 14" descr="Health Insurance Icon SVG Vector &amp; PNG Free Download | UXWing">
+            <a:extLst>
+              <a:ext uri="{FF2B5EF4-FFF2-40B4-BE49-F238E27FC236}">
+                <a16:creationId xmlns:a16="http://schemas.microsoft.com/office/drawing/2014/main" id="{81723617-9649-E782-C566-F5093A044655}"/>
+              </a:ext>
+            </a:extLst>
+          </p:cNvPr>
+          <p:cNvPicPr>
+            <a:picLocks noChangeAspect="1" noChangeArrowheads="1"/>
+          </p:cNvPicPr>
+          <p:nvPr/>
+        </p:nvPicPr>
+        <p:blipFill>
+          <a:blip r:embed="rId4">
+            <a:extLst>
+              <a:ext uri="{28A0092B-C50C-407E-A947-70E740481C1C}">
+                <a14:useLocalDpi xmlns:a14="http://schemas.microsoft.com/office/drawing/2010/main" val="0"/>
+              </a:ext>
+            </a:extLst>
+          </a:blip>
+          <a:srcRect/>
+          <a:stretch>
+            <a:fillRect/>
+          </a:stretch>
+        </p:blipFill>
+        <p:spPr bwMode="auto">
+          <a:xfrm>
+            <a:off x="8005303" y="3269456"/>
+            <a:ext cx="788653" cy="771282"/>
+          </a:xfrm>
+          <a:prstGeom prst="rect">
+            <a:avLst/>
+          </a:prstGeom>
+          <a:noFill/>
+          <a:extLst>
+            <a:ext uri="{909E8E84-426E-40DD-AFC4-6F175D3DCCD1}">
+              <a14:hiddenFill xmlns:a14="http://schemas.microsoft.com/office/drawing/2010/main">
+                <a:solidFill>
+                  <a:srgbClr val="FFFFFF"/>
+                </a:solidFill>
+              </a14:hiddenFill>
+            </a:ext>
+          </a:extLst>
+        </p:spPr>
+      </p:pic>
+      <p:pic>
+        <p:nvPicPr>
+          <p:cNvPr id="1042" name="Picture 18" descr="Database Icons - Free SVG &amp; PNG Database Images - Noun Project">
+            <a:extLst>
+              <a:ext uri="{FF2B5EF4-FFF2-40B4-BE49-F238E27FC236}">
+                <a16:creationId xmlns:a16="http://schemas.microsoft.com/office/drawing/2014/main" id="{5E4C4443-245C-2CDD-C0BD-31818C089663}"/>
+              </a:ext>
+            </a:extLst>
+          </p:cNvPr>
+          <p:cNvPicPr>
+            <a:picLocks noChangeAspect="1" noChangeArrowheads="1"/>
+          </p:cNvPicPr>
+          <p:nvPr/>
+        </p:nvPicPr>
+        <p:blipFill>
+          <a:blip r:embed="rId5">
+            <a:extLst>
+              <a:ext uri="{28A0092B-C50C-407E-A947-70E740481C1C}">
+                <a14:useLocalDpi xmlns:a14="http://schemas.microsoft.com/office/drawing/2010/main" val="0"/>
+              </a:ext>
+            </a:extLst>
+          </a:blip>
+          <a:srcRect/>
+          <a:stretch>
+            <a:fillRect/>
+          </a:stretch>
+        </p:blipFill>
+        <p:spPr bwMode="auto">
+          <a:xfrm>
+            <a:off x="5324718" y="3429000"/>
+            <a:ext cx="771282" cy="771282"/>
+          </a:xfrm>
+          <a:prstGeom prst="rect">
+            <a:avLst/>
+          </a:prstGeom>
+          <a:noFill/>
+          <a:extLst>
+            <a:ext uri="{909E8E84-426E-40DD-AFC4-6F175D3DCCD1}">
+              <a14:hiddenFill xmlns:a14="http://schemas.microsoft.com/office/drawing/2010/main">
+                <a:solidFill>
+                  <a:srgbClr val="FFFFFF"/>
+                </a:solidFill>
+              </a14:hiddenFill>
+            </a:ext>
+          </a:extLst>
+        </p:spPr>
+      </p:pic>
+      <p:sp>
+        <p:nvSpPr>
+          <p:cNvPr id="6" name="TextBox 5">
+            <a:extLst>
+              <a:ext uri="{FF2B5EF4-FFF2-40B4-BE49-F238E27FC236}">
+                <a16:creationId xmlns:a16="http://schemas.microsoft.com/office/drawing/2014/main" id="{9CBA59FC-7B7A-317D-B923-946A999840C5}"/>
+              </a:ext>
+            </a:extLst>
+          </p:cNvPr>
+          <p:cNvSpPr txBox="1"/>
+          <p:nvPr/>
+        </p:nvSpPr>
+        <p:spPr>
+          <a:xfrm>
+            <a:off x="5059901" y="2236677"/>
+            <a:ext cx="1300915" cy="646331"/>
+          </a:xfrm>
+          <a:prstGeom prst="rect">
+            <a:avLst/>
+          </a:prstGeom>
+          <a:noFill/>
+        </p:spPr>
+        <p:txBody>
+          <a:bodyPr wrap="square" rtlCol="0">
+            <a:spAutoFit/>
+          </a:bodyPr>
+          <a:lstStyle/>
+          <a:p>
+            <a:pPr algn="ctr"/>
+            <a:r>
+              <a:rPr lang="en-US" b="1" dirty="0"/>
+              <a:t>Reporting System</a:t>
+            </a:r>
+          </a:p>
+        </p:txBody>
+      </p:sp>
+      <p:sp>
+        <p:nvSpPr>
+          <p:cNvPr id="7" name="TextBox 6">
+            <a:extLst>
+              <a:ext uri="{FF2B5EF4-FFF2-40B4-BE49-F238E27FC236}">
+                <a16:creationId xmlns:a16="http://schemas.microsoft.com/office/drawing/2014/main" id="{69E93F34-B8EB-1821-9761-A0E44E19F8E8}"/>
+              </a:ext>
+            </a:extLst>
+          </p:cNvPr>
+          <p:cNvSpPr txBox="1"/>
+          <p:nvPr/>
+        </p:nvSpPr>
+        <p:spPr>
+          <a:xfrm>
+            <a:off x="8015870" y="2375177"/>
+            <a:ext cx="767518" cy="369332"/>
+          </a:xfrm>
+          <a:prstGeom prst="rect">
+            <a:avLst/>
+          </a:prstGeom>
+          <a:noFill/>
+        </p:spPr>
+        <p:txBody>
+          <a:bodyPr wrap="none" rtlCol="0">
+            <a:spAutoFit/>
+          </a:bodyPr>
+          <a:lstStyle/>
+          <a:p>
+            <a:pPr algn="ctr"/>
+            <a:r>
+              <a:rPr lang="en-US" b="1" dirty="0"/>
+              <a:t>Payer</a:t>
+            </a:r>
+          </a:p>
+        </p:txBody>
+      </p:sp>
+      <p:sp>
+        <p:nvSpPr>
+          <p:cNvPr id="9" name="Left Brace 8">
+            <a:extLst>
+              <a:ext uri="{FF2B5EF4-FFF2-40B4-BE49-F238E27FC236}">
+                <a16:creationId xmlns:a16="http://schemas.microsoft.com/office/drawing/2014/main" id="{B6DDA5E0-1980-B6EB-28E1-8BB3C7D5F93D}"/>
+              </a:ext>
+            </a:extLst>
+          </p:cNvPr>
+          <p:cNvSpPr/>
+          <p:nvPr/>
+        </p:nvSpPr>
+        <p:spPr>
+          <a:xfrm rot="16200000">
+            <a:off x="6954105" y="3634877"/>
+            <a:ext cx="397372" cy="2493679"/>
+          </a:xfrm>
+          <a:prstGeom prst="leftBrace">
+            <a:avLst>
+              <a:gd name="adj1" fmla="val 57063"/>
+              <a:gd name="adj2" fmla="val 50000"/>
+            </a:avLst>
+          </a:prstGeom>
+          <a:ln w="38100"/>
+        </p:spPr>
+        <p:style>
+          <a:lnRef idx="3">
+            <a:schemeClr val="dk1"/>
+          </a:lnRef>
+          <a:fillRef idx="0">
+            <a:schemeClr val="dk1"/>
+          </a:fillRef>
+          <a:effectRef idx="2">
+            <a:schemeClr val="dk1"/>
+          </a:effectRef>
+          <a:fontRef idx="minor">
+            <a:schemeClr val="tx1"/>
+          </a:fontRef>
+        </p:style>
+        <p:txBody>
+          <a:bodyPr rtlCol="0" anchor="ctr"/>
+          <a:lstStyle/>
+          <a:p>
+            <a:pPr algn="ctr"/>
+            <a:endParaRPr lang="en-US"/>
+          </a:p>
+        </p:txBody>
+      </p:sp>
+      <p:sp>
+        <p:nvSpPr>
+          <p:cNvPr id="11" name="TextBox 10">
+            <a:extLst>
+              <a:ext uri="{FF2B5EF4-FFF2-40B4-BE49-F238E27FC236}">
+                <a16:creationId xmlns:a16="http://schemas.microsoft.com/office/drawing/2014/main" id="{CB5399F2-C254-6FF7-F961-4C7EE68D5079}"/>
+              </a:ext>
+            </a:extLst>
+          </p:cNvPr>
+          <p:cNvSpPr txBox="1"/>
+          <p:nvPr/>
+        </p:nvSpPr>
+        <p:spPr>
+          <a:xfrm>
+            <a:off x="6543373" y="5193821"/>
+            <a:ext cx="1207382" cy="369332"/>
+          </a:xfrm>
+          <a:prstGeom prst="rect">
+            <a:avLst/>
+          </a:prstGeom>
+          <a:noFill/>
+        </p:spPr>
+        <p:txBody>
+          <a:bodyPr wrap="none" rtlCol="0">
+            <a:spAutoFit/>
+          </a:bodyPr>
+          <a:lstStyle/>
+          <a:p>
+            <a:pPr algn="ctr"/>
+            <a:r>
+              <a:rPr lang="en-US" b="1" dirty="0"/>
+              <a:t>Reporting</a:t>
+            </a:r>
+          </a:p>
+        </p:txBody>
+      </p:sp>
+      <p:sp>
+        <p:nvSpPr>
+          <p:cNvPr id="3" name="Content Placeholder 2">
+            <a:extLst>
+              <a:ext uri="{FF2B5EF4-FFF2-40B4-BE49-F238E27FC236}">
+                <a16:creationId xmlns:a16="http://schemas.microsoft.com/office/drawing/2014/main" id="{4996A15E-A599-2FE6-5F3A-52121833CEA3}"/>
+              </a:ext>
+            </a:extLst>
+          </p:cNvPr>
+          <p:cNvSpPr>
+            <a:spLocks noGrp="1"/>
+          </p:cNvSpPr>
+          <p:nvPr>
+            <p:ph sz="half" idx="1"/>
+          </p:nvPr>
+        </p:nvSpPr>
+        <p:spPr>
+          <a:xfrm>
+            <a:off x="838200" y="1825625"/>
+            <a:ext cx="3765383" cy="4351338"/>
+          </a:xfrm>
+        </p:spPr>
+        <p:txBody>
+          <a:bodyPr/>
+          <a:lstStyle/>
+          <a:p>
+            <a:pPr marL="514350" indent="-514350">
+              <a:buAutoNum type="arabicPeriod"/>
+            </a:pPr>
+            <a:r>
+              <a:rPr lang="en-US" dirty="0"/>
+              <a:t>Summary</a:t>
+            </a:r>
+          </a:p>
+          <a:p>
+            <a:pPr marL="971550" lvl="1" indent="-514350">
+              <a:buAutoNum type="arabicPeriod"/>
+            </a:pPr>
+            <a:r>
+              <a:rPr lang="en-US" dirty="0"/>
+              <a:t>e.g. EC/EP</a:t>
+            </a:r>
+          </a:p>
+          <a:p>
+            <a:pPr marL="971550" lvl="1" indent="-514350">
+              <a:buAutoNum type="arabicPeriod"/>
+            </a:pPr>
+            <a:r>
+              <a:rPr lang="en-US" dirty="0"/>
+              <a:t>Population-level reporting without supporting data</a:t>
+            </a:r>
+          </a:p>
+          <a:p>
+            <a:pPr marL="514350" indent="-514350">
+              <a:buAutoNum type="arabicPeriod"/>
+            </a:pPr>
+            <a:r>
+              <a:rPr lang="en-US" dirty="0"/>
+              <a:t>Individual</a:t>
+            </a:r>
+          </a:p>
+          <a:p>
+            <a:pPr marL="971550" lvl="1" indent="-514350">
+              <a:buAutoNum type="arabicPeriod"/>
+            </a:pPr>
+            <a:r>
+              <a:rPr lang="en-US" dirty="0"/>
+              <a:t>e.g. EH</a:t>
+            </a:r>
+          </a:p>
+          <a:p>
+            <a:pPr marL="971550" lvl="1" indent="-514350">
+              <a:buAutoNum type="arabicPeriod"/>
+            </a:pPr>
+            <a:r>
+              <a:rPr lang="en-US" dirty="0"/>
+              <a:t>Population-level reporting with supporting data</a:t>
+            </a:r>
+          </a:p>
+        </p:txBody>
+      </p:sp>
+    </p:spTree>
+    <p:extLst>
+      <p:ext uri="{BB962C8B-B14F-4D97-AF65-F5344CB8AC3E}">
+        <p14:creationId xmlns:p14="http://schemas.microsoft.com/office/powerpoint/2010/main" val="818937061"/>
+      </p:ext>
+    </p:extLst>
+  </p:cSld>
+  <p:clrMapOvr>
+    <a:masterClrMapping/>
+  </p:clrMapOvr>
+</p:sld>
+</file>
+
 <file path=ppt/slides/slide2.xml><?xml version="1.0" encoding="utf-8"?>
 <p:sld xmlns:a="http://schemas.openxmlformats.org/drawingml/2006/main" xmlns:r="http://schemas.openxmlformats.org/officeDocument/2006/relationships" xmlns:p="http://schemas.openxmlformats.org/presentationml/2006/main">
   <p:cSld>
@@ -10121,6 +11716,1066 @@
     <p:extLst>
       <p:ext uri="{BB962C8B-B14F-4D97-AF65-F5344CB8AC3E}">
         <p14:creationId xmlns:p14="http://schemas.microsoft.com/office/powerpoint/2010/main" val="826301999"/>
+      </p:ext>
+    </p:extLst>
+  </p:cSld>
+  <p:clrMapOvr>
+    <a:masterClrMapping/>
+  </p:clrMapOvr>
+</p:sld>
+</file>
+
+<file path=ppt/slides/slide8.xml><?xml version="1.0" encoding="utf-8"?>
+<p:sld xmlns:a="http://schemas.openxmlformats.org/drawingml/2006/main" xmlns:r="http://schemas.openxmlformats.org/officeDocument/2006/relationships" xmlns:p="http://schemas.openxmlformats.org/presentationml/2006/main">
+  <p:cSld>
+    <p:spTree>
+      <p:nvGrpSpPr>
+        <p:cNvPr id="1" name=""/>
+        <p:cNvGrpSpPr/>
+        <p:nvPr/>
+      </p:nvGrpSpPr>
+      <p:grpSpPr>
+        <a:xfrm>
+          <a:off x="0" y="0"/>
+          <a:ext cx="0" cy="0"/>
+          <a:chOff x="0" y="0"/>
+          <a:chExt cx="0" cy="0"/>
+        </a:xfrm>
+      </p:grpSpPr>
+      <p:sp>
+        <p:nvSpPr>
+          <p:cNvPr id="2" name="Title 1">
+            <a:extLst>
+              <a:ext uri="{FF2B5EF4-FFF2-40B4-BE49-F238E27FC236}">
+                <a16:creationId xmlns:a16="http://schemas.microsoft.com/office/drawing/2014/main" id="{8F7180DF-597C-EF7D-30B1-C0DC7BCF4A4D}"/>
+              </a:ext>
+            </a:extLst>
+          </p:cNvPr>
+          <p:cNvSpPr>
+            <a:spLocks noGrp="1"/>
+          </p:cNvSpPr>
+          <p:nvPr>
+            <p:ph type="title"/>
+          </p:nvPr>
+        </p:nvSpPr>
+        <p:spPr/>
+        <p:txBody>
+          <a:bodyPr/>
+          <a:lstStyle/>
+          <a:p>
+            <a:r>
+              <a:rPr lang="en-US" dirty="0"/>
+              <a:t>FHIR Quality Reporting with DEQM</a:t>
+            </a:r>
+          </a:p>
+        </p:txBody>
+      </p:sp>
+      <p:pic>
+        <p:nvPicPr>
+          <p:cNvPr id="1026" name="Picture 2" descr="Hospital buildings - Free medical icons">
+            <a:extLst>
+              <a:ext uri="{FF2B5EF4-FFF2-40B4-BE49-F238E27FC236}">
+                <a16:creationId xmlns:a16="http://schemas.microsoft.com/office/drawing/2014/main" id="{269F61C5-6D11-B27C-C21F-A928A269B8CC}"/>
+              </a:ext>
+            </a:extLst>
+          </p:cNvPr>
+          <p:cNvPicPr>
+            <a:picLocks noChangeAspect="1" noChangeArrowheads="1"/>
+          </p:cNvPicPr>
+          <p:nvPr/>
+        </p:nvPicPr>
+        <p:blipFill>
+          <a:blip r:embed="rId2">
+            <a:extLst>
+              <a:ext uri="{28A0092B-C50C-407E-A947-70E740481C1C}">
+                <a14:useLocalDpi xmlns:a14="http://schemas.microsoft.com/office/drawing/2010/main" val="0"/>
+              </a:ext>
+            </a:extLst>
+          </a:blip>
+          <a:srcRect/>
+          <a:stretch>
+            <a:fillRect/>
+          </a:stretch>
+        </p:blipFill>
+        <p:spPr bwMode="auto">
+          <a:xfrm flipH="1">
+            <a:off x="3029777" y="2934990"/>
+            <a:ext cx="771282" cy="771282"/>
+          </a:xfrm>
+          <a:prstGeom prst="rect">
+            <a:avLst/>
+          </a:prstGeom>
+          <a:noFill/>
+          <a:extLst>
+            <a:ext uri="{909E8E84-426E-40DD-AFC4-6F175D3DCCD1}">
+              <a14:hiddenFill xmlns:a14="http://schemas.microsoft.com/office/drawing/2010/main">
+                <a:solidFill>
+                  <a:srgbClr val="FFFFFF"/>
+                </a:solidFill>
+              </a14:hiddenFill>
+            </a:ext>
+          </a:extLst>
+        </p:spPr>
+      </p:pic>
+      <p:pic>
+        <p:nvPicPr>
+          <p:cNvPr id="1028" name="Picture 4" descr="Clinic Icons - Free SVG &amp; PNG Clinic Images - Noun Project">
+            <a:extLst>
+              <a:ext uri="{FF2B5EF4-FFF2-40B4-BE49-F238E27FC236}">
+                <a16:creationId xmlns:a16="http://schemas.microsoft.com/office/drawing/2014/main" id="{56E961AB-DCDD-9715-DD99-3FE143A105B5}"/>
+              </a:ext>
+            </a:extLst>
+          </p:cNvPr>
+          <p:cNvPicPr>
+            <a:picLocks noChangeAspect="1" noChangeArrowheads="1"/>
+          </p:cNvPicPr>
+          <p:nvPr/>
+        </p:nvPicPr>
+        <p:blipFill>
+          <a:blip r:embed="rId3">
+            <a:extLst>
+              <a:ext uri="{28A0092B-C50C-407E-A947-70E740481C1C}">
+                <a14:useLocalDpi xmlns:a14="http://schemas.microsoft.com/office/drawing/2010/main" val="0"/>
+              </a:ext>
+            </a:extLst>
+          </a:blip>
+          <a:srcRect/>
+          <a:stretch>
+            <a:fillRect/>
+          </a:stretch>
+        </p:blipFill>
+        <p:spPr bwMode="auto">
+          <a:xfrm>
+            <a:off x="3029777" y="3706272"/>
+            <a:ext cx="771282" cy="771282"/>
+          </a:xfrm>
+          <a:prstGeom prst="rect">
+            <a:avLst/>
+          </a:prstGeom>
+          <a:noFill/>
+          <a:extLst>
+            <a:ext uri="{909E8E84-426E-40DD-AFC4-6F175D3DCCD1}">
+              <a14:hiddenFill xmlns:a14="http://schemas.microsoft.com/office/drawing/2010/main">
+                <a:solidFill>
+                  <a:srgbClr val="FFFFFF"/>
+                </a:solidFill>
+              </a14:hiddenFill>
+            </a:ext>
+          </a:extLst>
+        </p:spPr>
+      </p:pic>
+      <p:pic>
+        <p:nvPicPr>
+          <p:cNvPr id="1032" name="Picture 8" descr="Monthly Report Icons - Free SVG &amp; PNG Monthly Report Images ...">
+            <a:extLst>
+              <a:ext uri="{FF2B5EF4-FFF2-40B4-BE49-F238E27FC236}">
+                <a16:creationId xmlns:a16="http://schemas.microsoft.com/office/drawing/2014/main" id="{65609946-5E06-679B-96CA-363B8E5441BA}"/>
+              </a:ext>
+            </a:extLst>
+          </p:cNvPr>
+          <p:cNvPicPr>
+            <a:picLocks noChangeAspect="1" noChangeArrowheads="1"/>
+          </p:cNvPicPr>
+          <p:nvPr/>
+        </p:nvPicPr>
+        <p:blipFill>
+          <a:blip r:embed="rId4">
+            <a:extLst>
+              <a:ext uri="{28A0092B-C50C-407E-A947-70E740481C1C}">
+                <a14:useLocalDpi xmlns:a14="http://schemas.microsoft.com/office/drawing/2010/main" val="0"/>
+              </a:ext>
+            </a:extLst>
+          </a:blip>
+          <a:srcRect/>
+          <a:stretch>
+            <a:fillRect/>
+          </a:stretch>
+        </p:blipFill>
+        <p:spPr bwMode="auto">
+          <a:xfrm>
+            <a:off x="6937960" y="3493546"/>
+            <a:ext cx="418204" cy="418204"/>
+          </a:xfrm>
+          <a:prstGeom prst="rect">
+            <a:avLst/>
+          </a:prstGeom>
+          <a:noFill/>
+          <a:extLst>
+            <a:ext uri="{909E8E84-426E-40DD-AFC4-6F175D3DCCD1}">
+              <a14:hiddenFill xmlns:a14="http://schemas.microsoft.com/office/drawing/2010/main">
+                <a:solidFill>
+                  <a:srgbClr val="FFFFFF"/>
+                </a:solidFill>
+              </a14:hiddenFill>
+            </a:ext>
+          </a:extLst>
+        </p:spPr>
+      </p:pic>
+      <p:pic>
+        <p:nvPicPr>
+          <p:cNvPr id="1034" name="Picture 10" descr="Engine Gears Icon SVG Vector &amp; PNG Free Download | UXWing">
+            <a:extLst>
+              <a:ext uri="{FF2B5EF4-FFF2-40B4-BE49-F238E27FC236}">
+                <a16:creationId xmlns:a16="http://schemas.microsoft.com/office/drawing/2014/main" id="{A5AEA72A-1709-4180-57A4-03FBC3838835}"/>
+              </a:ext>
+            </a:extLst>
+          </p:cNvPr>
+          <p:cNvPicPr>
+            <a:picLocks noChangeAspect="1" noChangeArrowheads="1"/>
+          </p:cNvPicPr>
+          <p:nvPr/>
+        </p:nvPicPr>
+        <p:blipFill>
+          <a:blip r:embed="rId5">
+            <a:extLst>
+              <a:ext uri="{28A0092B-C50C-407E-A947-70E740481C1C}">
+                <a14:useLocalDpi xmlns:a14="http://schemas.microsoft.com/office/drawing/2010/main" val="0"/>
+              </a:ext>
+            </a:extLst>
+          </a:blip>
+          <a:srcRect/>
+          <a:stretch>
+            <a:fillRect/>
+          </a:stretch>
+        </p:blipFill>
+        <p:spPr bwMode="auto">
+          <a:xfrm>
+            <a:off x="5710360" y="3172347"/>
+            <a:ext cx="771282" cy="873632"/>
+          </a:xfrm>
+          <a:prstGeom prst="rect">
+            <a:avLst/>
+          </a:prstGeom>
+          <a:noFill/>
+          <a:extLst>
+            <a:ext uri="{909E8E84-426E-40DD-AFC4-6F175D3DCCD1}">
+              <a14:hiddenFill xmlns:a14="http://schemas.microsoft.com/office/drawing/2010/main">
+                <a:solidFill>
+                  <a:srgbClr val="FFFFFF"/>
+                </a:solidFill>
+              </a14:hiddenFill>
+            </a:ext>
+          </a:extLst>
+        </p:spPr>
+      </p:pic>
+      <p:pic>
+        <p:nvPicPr>
+          <p:cNvPr id="1038" name="Picture 14" descr="Health Insurance Icon SVG Vector &amp; PNG Free Download | UXWing">
+            <a:extLst>
+              <a:ext uri="{FF2B5EF4-FFF2-40B4-BE49-F238E27FC236}">
+                <a16:creationId xmlns:a16="http://schemas.microsoft.com/office/drawing/2014/main" id="{13194239-0D3C-400E-A359-107425B01570}"/>
+              </a:ext>
+            </a:extLst>
+          </p:cNvPr>
+          <p:cNvPicPr>
+            <a:picLocks noChangeAspect="1" noChangeArrowheads="1"/>
+          </p:cNvPicPr>
+          <p:nvPr/>
+        </p:nvPicPr>
+        <p:blipFill>
+          <a:blip r:embed="rId6">
+            <a:extLst>
+              <a:ext uri="{28A0092B-C50C-407E-A947-70E740481C1C}">
+                <a14:useLocalDpi xmlns:a14="http://schemas.microsoft.com/office/drawing/2010/main" val="0"/>
+              </a:ext>
+            </a:extLst>
+          </a:blip>
+          <a:srcRect/>
+          <a:stretch>
+            <a:fillRect/>
+          </a:stretch>
+        </p:blipFill>
+        <p:spPr bwMode="auto">
+          <a:xfrm>
+            <a:off x="8005303" y="3269456"/>
+            <a:ext cx="788653" cy="771282"/>
+          </a:xfrm>
+          <a:prstGeom prst="rect">
+            <a:avLst/>
+          </a:prstGeom>
+          <a:noFill/>
+          <a:extLst>
+            <a:ext uri="{909E8E84-426E-40DD-AFC4-6F175D3DCCD1}">
+              <a14:hiddenFill xmlns:a14="http://schemas.microsoft.com/office/drawing/2010/main">
+                <a:solidFill>
+                  <a:srgbClr val="FFFFFF"/>
+                </a:solidFill>
+              </a14:hiddenFill>
+            </a:ext>
+          </a:extLst>
+        </p:spPr>
+      </p:pic>
+      <p:pic>
+        <p:nvPicPr>
+          <p:cNvPr id="1040" name="Picture 16" descr="Documents symbol - Free interface icons">
+            <a:extLst>
+              <a:ext uri="{FF2B5EF4-FFF2-40B4-BE49-F238E27FC236}">
+                <a16:creationId xmlns:a16="http://schemas.microsoft.com/office/drawing/2014/main" id="{DB61FA4D-4512-17AA-62DF-4220D00C1ABF}"/>
+              </a:ext>
+            </a:extLst>
+          </p:cNvPr>
+          <p:cNvPicPr>
+            <a:picLocks noChangeAspect="1" noChangeArrowheads="1"/>
+          </p:cNvPicPr>
+          <p:nvPr/>
+        </p:nvPicPr>
+        <p:blipFill>
+          <a:blip r:embed="rId7">
+            <a:extLst>
+              <a:ext uri="{28A0092B-C50C-407E-A947-70E740481C1C}">
+                <a14:useLocalDpi xmlns:a14="http://schemas.microsoft.com/office/drawing/2010/main" val="0"/>
+              </a:ext>
+            </a:extLst>
+          </a:blip>
+          <a:srcRect/>
+          <a:stretch>
+            <a:fillRect/>
+          </a:stretch>
+        </p:blipFill>
+        <p:spPr bwMode="auto">
+          <a:xfrm>
+            <a:off x="4450197" y="3493546"/>
+            <a:ext cx="418204" cy="418204"/>
+          </a:xfrm>
+          <a:prstGeom prst="rect">
+            <a:avLst/>
+          </a:prstGeom>
+          <a:noFill/>
+          <a:extLst>
+            <a:ext uri="{909E8E84-426E-40DD-AFC4-6F175D3DCCD1}">
+              <a14:hiddenFill xmlns:a14="http://schemas.microsoft.com/office/drawing/2010/main">
+                <a:solidFill>
+                  <a:srgbClr val="FFFFFF"/>
+                </a:solidFill>
+              </a14:hiddenFill>
+            </a:ext>
+          </a:extLst>
+        </p:spPr>
+      </p:pic>
+      <p:pic>
+        <p:nvPicPr>
+          <p:cNvPr id="1042" name="Picture 18" descr="Database Icons - Free SVG &amp; PNG Database Images - Noun Project">
+            <a:extLst>
+              <a:ext uri="{FF2B5EF4-FFF2-40B4-BE49-F238E27FC236}">
+                <a16:creationId xmlns:a16="http://schemas.microsoft.com/office/drawing/2014/main" id="{E12BBF33-B1B8-B7B2-9783-FD6C34B3DB83}"/>
+              </a:ext>
+            </a:extLst>
+          </p:cNvPr>
+          <p:cNvPicPr>
+            <a:picLocks noChangeAspect="1" noChangeArrowheads="1"/>
+          </p:cNvPicPr>
+          <p:nvPr/>
+        </p:nvPicPr>
+        <p:blipFill>
+          <a:blip r:embed="rId8">
+            <a:extLst>
+              <a:ext uri="{28A0092B-C50C-407E-A947-70E740481C1C}">
+                <a14:useLocalDpi xmlns:a14="http://schemas.microsoft.com/office/drawing/2010/main" val="0"/>
+              </a:ext>
+            </a:extLst>
+          </a:blip>
+          <a:srcRect/>
+          <a:stretch>
+            <a:fillRect/>
+          </a:stretch>
+        </p:blipFill>
+        <p:spPr bwMode="auto">
+          <a:xfrm>
+            <a:off x="5324718" y="3429000"/>
+            <a:ext cx="771282" cy="771282"/>
+          </a:xfrm>
+          <a:prstGeom prst="rect">
+            <a:avLst/>
+          </a:prstGeom>
+          <a:noFill/>
+          <a:extLst>
+            <a:ext uri="{909E8E84-426E-40DD-AFC4-6F175D3DCCD1}">
+              <a14:hiddenFill xmlns:a14="http://schemas.microsoft.com/office/drawing/2010/main">
+                <a:solidFill>
+                  <a:srgbClr val="FFFFFF"/>
+                </a:solidFill>
+              </a14:hiddenFill>
+            </a:ext>
+          </a:extLst>
+        </p:spPr>
+      </p:pic>
+      <p:sp>
+        <p:nvSpPr>
+          <p:cNvPr id="5" name="TextBox 4">
+            <a:extLst>
+              <a:ext uri="{FF2B5EF4-FFF2-40B4-BE49-F238E27FC236}">
+                <a16:creationId xmlns:a16="http://schemas.microsoft.com/office/drawing/2014/main" id="{857515F1-1129-1ADC-A4BC-259F8560C23C}"/>
+              </a:ext>
+            </a:extLst>
+          </p:cNvPr>
+          <p:cNvSpPr txBox="1"/>
+          <p:nvPr/>
+        </p:nvSpPr>
+        <p:spPr>
+          <a:xfrm>
+            <a:off x="2885786" y="2375177"/>
+            <a:ext cx="1059264" cy="369332"/>
+          </a:xfrm>
+          <a:prstGeom prst="rect">
+            <a:avLst/>
+          </a:prstGeom>
+          <a:noFill/>
+        </p:spPr>
+        <p:txBody>
+          <a:bodyPr wrap="none" rtlCol="0">
+            <a:spAutoFit/>
+          </a:bodyPr>
+          <a:lstStyle/>
+          <a:p>
+            <a:pPr algn="ctr"/>
+            <a:r>
+              <a:rPr lang="en-US" b="1" dirty="0"/>
+              <a:t>Provider</a:t>
+            </a:r>
+          </a:p>
+        </p:txBody>
+      </p:sp>
+      <p:sp>
+        <p:nvSpPr>
+          <p:cNvPr id="6" name="TextBox 5">
+            <a:extLst>
+              <a:ext uri="{FF2B5EF4-FFF2-40B4-BE49-F238E27FC236}">
+                <a16:creationId xmlns:a16="http://schemas.microsoft.com/office/drawing/2014/main" id="{111F995D-BDBF-6411-EA31-333F3E96E09A}"/>
+              </a:ext>
+            </a:extLst>
+          </p:cNvPr>
+          <p:cNvSpPr txBox="1"/>
+          <p:nvPr/>
+        </p:nvSpPr>
+        <p:spPr>
+          <a:xfrm>
+            <a:off x="5059901" y="2236677"/>
+            <a:ext cx="1300915" cy="646331"/>
+          </a:xfrm>
+          <a:prstGeom prst="rect">
+            <a:avLst/>
+          </a:prstGeom>
+          <a:noFill/>
+        </p:spPr>
+        <p:txBody>
+          <a:bodyPr wrap="square" rtlCol="0">
+            <a:spAutoFit/>
+          </a:bodyPr>
+          <a:lstStyle/>
+          <a:p>
+            <a:pPr algn="ctr"/>
+            <a:r>
+              <a:rPr lang="en-US" b="1" dirty="0"/>
+              <a:t>Reporting System</a:t>
+            </a:r>
+          </a:p>
+        </p:txBody>
+      </p:sp>
+      <p:sp>
+        <p:nvSpPr>
+          <p:cNvPr id="7" name="TextBox 6">
+            <a:extLst>
+              <a:ext uri="{FF2B5EF4-FFF2-40B4-BE49-F238E27FC236}">
+                <a16:creationId xmlns:a16="http://schemas.microsoft.com/office/drawing/2014/main" id="{3EC6FED4-AA87-80D2-D0B5-60759810E2D6}"/>
+              </a:ext>
+            </a:extLst>
+          </p:cNvPr>
+          <p:cNvSpPr txBox="1"/>
+          <p:nvPr/>
+        </p:nvSpPr>
+        <p:spPr>
+          <a:xfrm>
+            <a:off x="8015870" y="2375177"/>
+            <a:ext cx="767518" cy="369332"/>
+          </a:xfrm>
+          <a:prstGeom prst="rect">
+            <a:avLst/>
+          </a:prstGeom>
+          <a:noFill/>
+        </p:spPr>
+        <p:txBody>
+          <a:bodyPr wrap="none" rtlCol="0">
+            <a:spAutoFit/>
+          </a:bodyPr>
+          <a:lstStyle/>
+          <a:p>
+            <a:pPr algn="ctr"/>
+            <a:r>
+              <a:rPr lang="en-US" b="1" dirty="0"/>
+              <a:t>Payer</a:t>
+            </a:r>
+          </a:p>
+        </p:txBody>
+      </p:sp>
+      <p:sp>
+        <p:nvSpPr>
+          <p:cNvPr id="8" name="Left Brace 7">
+            <a:extLst>
+              <a:ext uri="{FF2B5EF4-FFF2-40B4-BE49-F238E27FC236}">
+                <a16:creationId xmlns:a16="http://schemas.microsoft.com/office/drawing/2014/main" id="{3756E120-56B6-5A74-A934-057F7421F6A4}"/>
+              </a:ext>
+            </a:extLst>
+          </p:cNvPr>
+          <p:cNvSpPr/>
+          <p:nvPr/>
+        </p:nvSpPr>
+        <p:spPr>
+          <a:xfrm rot="16200000">
+            <a:off x="4408212" y="3690240"/>
+            <a:ext cx="397372" cy="2382955"/>
+          </a:xfrm>
+          <a:prstGeom prst="leftBrace">
+            <a:avLst>
+              <a:gd name="adj1" fmla="val 57063"/>
+              <a:gd name="adj2" fmla="val 50000"/>
+            </a:avLst>
+          </a:prstGeom>
+          <a:ln w="38100"/>
+        </p:spPr>
+        <p:style>
+          <a:lnRef idx="3">
+            <a:schemeClr val="dk1"/>
+          </a:lnRef>
+          <a:fillRef idx="0">
+            <a:schemeClr val="dk1"/>
+          </a:fillRef>
+          <a:effectRef idx="2">
+            <a:schemeClr val="dk1"/>
+          </a:effectRef>
+          <a:fontRef idx="minor">
+            <a:schemeClr val="tx1"/>
+          </a:fontRef>
+        </p:style>
+        <p:txBody>
+          <a:bodyPr rtlCol="0" anchor="ctr"/>
+          <a:lstStyle/>
+          <a:p>
+            <a:pPr algn="ctr"/>
+            <a:endParaRPr lang="en-US"/>
+          </a:p>
+        </p:txBody>
+      </p:sp>
+      <p:sp>
+        <p:nvSpPr>
+          <p:cNvPr id="9" name="Left Brace 8">
+            <a:extLst>
+              <a:ext uri="{FF2B5EF4-FFF2-40B4-BE49-F238E27FC236}">
+                <a16:creationId xmlns:a16="http://schemas.microsoft.com/office/drawing/2014/main" id="{A2E8F97F-BE9E-2C99-4CA3-06CA3A0F3CAE}"/>
+              </a:ext>
+            </a:extLst>
+          </p:cNvPr>
+          <p:cNvSpPr/>
+          <p:nvPr/>
+        </p:nvSpPr>
+        <p:spPr>
+          <a:xfrm rot="16200000">
+            <a:off x="6954105" y="3634877"/>
+            <a:ext cx="397372" cy="2493679"/>
+          </a:xfrm>
+          <a:prstGeom prst="leftBrace">
+            <a:avLst>
+              <a:gd name="adj1" fmla="val 57063"/>
+              <a:gd name="adj2" fmla="val 50000"/>
+            </a:avLst>
+          </a:prstGeom>
+          <a:ln w="38100"/>
+        </p:spPr>
+        <p:style>
+          <a:lnRef idx="3">
+            <a:schemeClr val="dk1"/>
+          </a:lnRef>
+          <a:fillRef idx="0">
+            <a:schemeClr val="dk1"/>
+          </a:fillRef>
+          <a:effectRef idx="2">
+            <a:schemeClr val="dk1"/>
+          </a:effectRef>
+          <a:fontRef idx="minor">
+            <a:schemeClr val="tx1"/>
+          </a:fontRef>
+        </p:style>
+        <p:txBody>
+          <a:bodyPr rtlCol="0" anchor="ctr"/>
+          <a:lstStyle/>
+          <a:p>
+            <a:pPr algn="ctr"/>
+            <a:endParaRPr lang="en-US"/>
+          </a:p>
+        </p:txBody>
+      </p:sp>
+      <p:sp>
+        <p:nvSpPr>
+          <p:cNvPr id="10" name="TextBox 9">
+            <a:extLst>
+              <a:ext uri="{FF2B5EF4-FFF2-40B4-BE49-F238E27FC236}">
+                <a16:creationId xmlns:a16="http://schemas.microsoft.com/office/drawing/2014/main" id="{FA3859C0-27AC-BE2E-2C7B-5DDE9D621C7A}"/>
+              </a:ext>
+            </a:extLst>
+          </p:cNvPr>
+          <p:cNvSpPr txBox="1"/>
+          <p:nvPr/>
+        </p:nvSpPr>
+        <p:spPr>
+          <a:xfrm>
+            <a:off x="4011576" y="5193821"/>
+            <a:ext cx="1190647" cy="369332"/>
+          </a:xfrm>
+          <a:prstGeom prst="rect">
+            <a:avLst/>
+          </a:prstGeom>
+          <a:noFill/>
+        </p:spPr>
+        <p:txBody>
+          <a:bodyPr wrap="none" rtlCol="0">
+            <a:spAutoFit/>
+          </a:bodyPr>
+          <a:lstStyle/>
+          <a:p>
+            <a:pPr algn="ctr"/>
+            <a:r>
+              <a:rPr lang="en-US" b="1" dirty="0"/>
+              <a:t>Exchange</a:t>
+            </a:r>
+          </a:p>
+        </p:txBody>
+      </p:sp>
+      <p:sp>
+        <p:nvSpPr>
+          <p:cNvPr id="11" name="TextBox 10">
+            <a:extLst>
+              <a:ext uri="{FF2B5EF4-FFF2-40B4-BE49-F238E27FC236}">
+                <a16:creationId xmlns:a16="http://schemas.microsoft.com/office/drawing/2014/main" id="{CDC628AC-FAFA-BC52-ED77-64753504FED7}"/>
+              </a:ext>
+            </a:extLst>
+          </p:cNvPr>
+          <p:cNvSpPr txBox="1"/>
+          <p:nvPr/>
+        </p:nvSpPr>
+        <p:spPr>
+          <a:xfrm>
+            <a:off x="6543373" y="5193821"/>
+            <a:ext cx="1207382" cy="369332"/>
+          </a:xfrm>
+          <a:prstGeom prst="rect">
+            <a:avLst/>
+          </a:prstGeom>
+          <a:noFill/>
+        </p:spPr>
+        <p:txBody>
+          <a:bodyPr wrap="none" rtlCol="0">
+            <a:spAutoFit/>
+          </a:bodyPr>
+          <a:lstStyle/>
+          <a:p>
+            <a:pPr algn="ctr"/>
+            <a:r>
+              <a:rPr lang="en-US" b="1" dirty="0"/>
+              <a:t>Reporting</a:t>
+            </a:r>
+          </a:p>
+        </p:txBody>
+      </p:sp>
+    </p:spTree>
+    <p:extLst>
+      <p:ext uri="{BB962C8B-B14F-4D97-AF65-F5344CB8AC3E}">
+        <p14:creationId xmlns:p14="http://schemas.microsoft.com/office/powerpoint/2010/main" val="2633206958"/>
+      </p:ext>
+    </p:extLst>
+  </p:cSld>
+  <p:clrMapOvr>
+    <a:masterClrMapping/>
+  </p:clrMapOvr>
+</p:sld>
+</file>
+
+<file path=ppt/slides/slide9.xml><?xml version="1.0" encoding="utf-8"?>
+<p:sld xmlns:a="http://schemas.openxmlformats.org/drawingml/2006/main" xmlns:r="http://schemas.openxmlformats.org/officeDocument/2006/relationships" xmlns:p="http://schemas.openxmlformats.org/presentationml/2006/main">
+  <p:cSld>
+    <p:spTree>
+      <p:nvGrpSpPr>
+        <p:cNvPr id="1" name="">
+          <a:extLst>
+            <a:ext uri="{FF2B5EF4-FFF2-40B4-BE49-F238E27FC236}">
+              <a16:creationId xmlns:a16="http://schemas.microsoft.com/office/drawing/2014/main" id="{0E9F0F2C-A5BD-41B4-D160-957F6A54A84C}"/>
+            </a:ext>
+          </a:extLst>
+        </p:cNvPr>
+        <p:cNvGrpSpPr/>
+        <p:nvPr/>
+      </p:nvGrpSpPr>
+      <p:grpSpPr>
+        <a:xfrm>
+          <a:off x="0" y="0"/>
+          <a:ext cx="0" cy="0"/>
+          <a:chOff x="0" y="0"/>
+          <a:chExt cx="0" cy="0"/>
+        </a:xfrm>
+      </p:grpSpPr>
+      <p:sp>
+        <p:nvSpPr>
+          <p:cNvPr id="2" name="Title 1">
+            <a:extLst>
+              <a:ext uri="{FF2B5EF4-FFF2-40B4-BE49-F238E27FC236}">
+                <a16:creationId xmlns:a16="http://schemas.microsoft.com/office/drawing/2014/main" id="{A8C3BD21-B8C8-46C1-6580-58522FC9B421}"/>
+              </a:ext>
+            </a:extLst>
+          </p:cNvPr>
+          <p:cNvSpPr>
+            <a:spLocks noGrp="1"/>
+          </p:cNvSpPr>
+          <p:nvPr>
+            <p:ph type="title"/>
+          </p:nvPr>
+        </p:nvSpPr>
+        <p:spPr/>
+        <p:txBody>
+          <a:bodyPr/>
+          <a:lstStyle/>
+          <a:p>
+            <a:r>
+              <a:rPr lang="en-US" dirty="0"/>
+              <a:t>Exchange Scope</a:t>
+            </a:r>
+          </a:p>
+        </p:txBody>
+      </p:sp>
+      <p:sp>
+        <p:nvSpPr>
+          <p:cNvPr id="5" name="TextBox 4">
+            <a:extLst>
+              <a:ext uri="{FF2B5EF4-FFF2-40B4-BE49-F238E27FC236}">
+                <a16:creationId xmlns:a16="http://schemas.microsoft.com/office/drawing/2014/main" id="{99F1E6B3-94A1-A2EB-CE8E-6546B3438F4E}"/>
+              </a:ext>
+            </a:extLst>
+          </p:cNvPr>
+          <p:cNvSpPr txBox="1"/>
+          <p:nvPr/>
+        </p:nvSpPr>
+        <p:spPr>
+          <a:xfrm>
+            <a:off x="2770243" y="2375177"/>
+            <a:ext cx="1290354" cy="369332"/>
+          </a:xfrm>
+          <a:prstGeom prst="rect">
+            <a:avLst/>
+          </a:prstGeom>
+          <a:noFill/>
+        </p:spPr>
+        <p:txBody>
+          <a:bodyPr wrap="none" rtlCol="0">
+            <a:spAutoFit/>
+          </a:bodyPr>
+          <a:lstStyle/>
+          <a:p>
+            <a:pPr algn="ctr"/>
+            <a:r>
+              <a:rPr lang="en-US" b="1" dirty="0"/>
+              <a:t>Everything</a:t>
+            </a:r>
+          </a:p>
+        </p:txBody>
+      </p:sp>
+      <p:sp>
+        <p:nvSpPr>
+          <p:cNvPr id="6" name="TextBox 5">
+            <a:extLst>
+              <a:ext uri="{FF2B5EF4-FFF2-40B4-BE49-F238E27FC236}">
+                <a16:creationId xmlns:a16="http://schemas.microsoft.com/office/drawing/2014/main" id="{5C56DD59-D28F-106C-4255-40AD6844ECED}"/>
+              </a:ext>
+            </a:extLst>
+          </p:cNvPr>
+          <p:cNvSpPr txBox="1"/>
+          <p:nvPr/>
+        </p:nvSpPr>
+        <p:spPr>
+          <a:xfrm>
+            <a:off x="5059901" y="2098178"/>
+            <a:ext cx="1483472" cy="923330"/>
+          </a:xfrm>
+          <a:prstGeom prst="rect">
+            <a:avLst/>
+          </a:prstGeom>
+          <a:noFill/>
+        </p:spPr>
+        <p:txBody>
+          <a:bodyPr wrap="square" rtlCol="0">
+            <a:spAutoFit/>
+          </a:bodyPr>
+          <a:lstStyle/>
+          <a:p>
+            <a:pPr algn="ctr"/>
+            <a:r>
+              <a:rPr lang="en-US" b="1" dirty="0"/>
+              <a:t>Program- or contract-specific</a:t>
+            </a:r>
+          </a:p>
+        </p:txBody>
+      </p:sp>
+      <p:sp>
+        <p:nvSpPr>
+          <p:cNvPr id="7" name="TextBox 6">
+            <a:extLst>
+              <a:ext uri="{FF2B5EF4-FFF2-40B4-BE49-F238E27FC236}">
+                <a16:creationId xmlns:a16="http://schemas.microsoft.com/office/drawing/2014/main" id="{37FE8C8A-B3B2-421F-52CC-BB79B7248D85}"/>
+              </a:ext>
+            </a:extLst>
+          </p:cNvPr>
+          <p:cNvSpPr txBox="1"/>
+          <p:nvPr/>
+        </p:nvSpPr>
+        <p:spPr>
+          <a:xfrm>
+            <a:off x="7542677" y="2236677"/>
+            <a:ext cx="1483472" cy="646331"/>
+          </a:xfrm>
+          <a:prstGeom prst="rect">
+            <a:avLst/>
+          </a:prstGeom>
+          <a:noFill/>
+        </p:spPr>
+        <p:txBody>
+          <a:bodyPr wrap="square" rtlCol="0">
+            <a:spAutoFit/>
+          </a:bodyPr>
+          <a:lstStyle/>
+          <a:p>
+            <a:pPr algn="ctr"/>
+            <a:r>
+              <a:rPr lang="en-US" b="1" dirty="0"/>
+              <a:t>Measure-specific</a:t>
+            </a:r>
+          </a:p>
+        </p:txBody>
+      </p:sp>
+      <p:sp>
+        <p:nvSpPr>
+          <p:cNvPr id="8" name="Left Brace 7">
+            <a:extLst>
+              <a:ext uri="{FF2B5EF4-FFF2-40B4-BE49-F238E27FC236}">
+                <a16:creationId xmlns:a16="http://schemas.microsoft.com/office/drawing/2014/main" id="{43AB74CC-1116-541C-FC7C-7CCBFCA1835C}"/>
+              </a:ext>
+            </a:extLst>
+          </p:cNvPr>
+          <p:cNvSpPr/>
+          <p:nvPr/>
+        </p:nvSpPr>
+        <p:spPr>
+          <a:xfrm rot="16200000">
+            <a:off x="5650720" y="2447733"/>
+            <a:ext cx="397372" cy="4867970"/>
+          </a:xfrm>
+          <a:prstGeom prst="leftBrace">
+            <a:avLst>
+              <a:gd name="adj1" fmla="val 57063"/>
+              <a:gd name="adj2" fmla="val 50000"/>
+            </a:avLst>
+          </a:prstGeom>
+          <a:ln w="38100"/>
+        </p:spPr>
+        <p:style>
+          <a:lnRef idx="3">
+            <a:schemeClr val="dk1"/>
+          </a:lnRef>
+          <a:fillRef idx="0">
+            <a:schemeClr val="dk1"/>
+          </a:fillRef>
+          <a:effectRef idx="2">
+            <a:schemeClr val="dk1"/>
+          </a:effectRef>
+          <a:fontRef idx="minor">
+            <a:schemeClr val="tx1"/>
+          </a:fontRef>
+        </p:style>
+        <p:txBody>
+          <a:bodyPr rtlCol="0" anchor="ctr"/>
+          <a:lstStyle/>
+          <a:p>
+            <a:pPr algn="ctr"/>
+            <a:endParaRPr lang="en-US"/>
+          </a:p>
+        </p:txBody>
+      </p:sp>
+      <p:sp>
+        <p:nvSpPr>
+          <p:cNvPr id="10" name="TextBox 9">
+            <a:extLst>
+              <a:ext uri="{FF2B5EF4-FFF2-40B4-BE49-F238E27FC236}">
+                <a16:creationId xmlns:a16="http://schemas.microsoft.com/office/drawing/2014/main" id="{92C7CE10-02F1-FDCE-8547-C1340A69242B}"/>
+              </a:ext>
+            </a:extLst>
+          </p:cNvPr>
+          <p:cNvSpPr txBox="1"/>
+          <p:nvPr/>
+        </p:nvSpPr>
+        <p:spPr>
+          <a:xfrm>
+            <a:off x="4963495" y="5104714"/>
+            <a:ext cx="2073003" cy="369332"/>
+          </a:xfrm>
+          <a:prstGeom prst="rect">
+            <a:avLst/>
+          </a:prstGeom>
+          <a:noFill/>
+        </p:spPr>
+        <p:txBody>
+          <a:bodyPr wrap="none" rtlCol="0">
+            <a:spAutoFit/>
+          </a:bodyPr>
+          <a:lstStyle/>
+          <a:p>
+            <a:pPr algn="ctr"/>
+            <a:r>
+              <a:rPr lang="en-US" b="1" dirty="0"/>
+              <a:t>Scope Continuum</a:t>
+            </a:r>
+          </a:p>
+        </p:txBody>
+      </p:sp>
+      <p:pic>
+        <p:nvPicPr>
+          <p:cNvPr id="2050" name="Picture 2" descr="Measure - Free edit tools icons">
+            <a:extLst>
+              <a:ext uri="{FF2B5EF4-FFF2-40B4-BE49-F238E27FC236}">
+                <a16:creationId xmlns:a16="http://schemas.microsoft.com/office/drawing/2014/main" id="{D7F4F606-6A9D-2FC1-DA12-2A57F949B759}"/>
+              </a:ext>
+            </a:extLst>
+          </p:cNvPr>
+          <p:cNvPicPr>
+            <a:picLocks noChangeAspect="1" noChangeArrowheads="1"/>
+          </p:cNvPicPr>
+          <p:nvPr/>
+        </p:nvPicPr>
+        <p:blipFill>
+          <a:blip r:embed="rId3">
+            <a:extLst>
+              <a:ext uri="{28A0092B-C50C-407E-A947-70E740481C1C}">
+                <a14:useLocalDpi xmlns:a14="http://schemas.microsoft.com/office/drawing/2010/main" val="0"/>
+              </a:ext>
+            </a:extLst>
+          </a:blip>
+          <a:srcRect/>
+          <a:stretch>
+            <a:fillRect/>
+          </a:stretch>
+        </p:blipFill>
+        <p:spPr bwMode="auto">
+          <a:xfrm flipH="1">
+            <a:off x="7847597" y="3265832"/>
+            <a:ext cx="873632" cy="873632"/>
+          </a:xfrm>
+          <a:prstGeom prst="rect">
+            <a:avLst/>
+          </a:prstGeom>
+          <a:noFill/>
+          <a:extLst>
+            <a:ext uri="{909E8E84-426E-40DD-AFC4-6F175D3DCCD1}">
+              <a14:hiddenFill xmlns:a14="http://schemas.microsoft.com/office/drawing/2010/main">
+                <a:solidFill>
+                  <a:srgbClr val="FFFFFF"/>
+                </a:solidFill>
+              </a14:hiddenFill>
+            </a:ext>
+          </a:extLst>
+        </p:spPr>
+      </p:pic>
+      <p:pic>
+        <p:nvPicPr>
+          <p:cNvPr id="2052" name="Picture 4" descr="Contract Icon SVG Vector &amp; PNG Free Download | UXWing">
+            <a:extLst>
+              <a:ext uri="{FF2B5EF4-FFF2-40B4-BE49-F238E27FC236}">
+                <a16:creationId xmlns:a16="http://schemas.microsoft.com/office/drawing/2014/main" id="{0204EBE1-158A-1D1B-E702-3D0CC103A1F7}"/>
+              </a:ext>
+            </a:extLst>
+          </p:cNvPr>
+          <p:cNvPicPr>
+            <a:picLocks noChangeAspect="1" noChangeArrowheads="1"/>
+          </p:cNvPicPr>
+          <p:nvPr/>
+        </p:nvPicPr>
+        <p:blipFill>
+          <a:blip r:embed="rId4">
+            <a:extLst>
+              <a:ext uri="{28A0092B-C50C-407E-A947-70E740481C1C}">
+                <a14:useLocalDpi xmlns:a14="http://schemas.microsoft.com/office/drawing/2010/main" val="0"/>
+              </a:ext>
+            </a:extLst>
+          </a:blip>
+          <a:srcRect/>
+          <a:stretch>
+            <a:fillRect/>
+          </a:stretch>
+        </p:blipFill>
+        <p:spPr bwMode="auto">
+          <a:xfrm>
+            <a:off x="5517539" y="3265832"/>
+            <a:ext cx="771281" cy="873632"/>
+          </a:xfrm>
+          <a:prstGeom prst="rect">
+            <a:avLst/>
+          </a:prstGeom>
+          <a:noFill/>
+          <a:extLst>
+            <a:ext uri="{909E8E84-426E-40DD-AFC4-6F175D3DCCD1}">
+              <a14:hiddenFill xmlns:a14="http://schemas.microsoft.com/office/drawing/2010/main">
+                <a:solidFill>
+                  <a:srgbClr val="FFFFFF"/>
+                </a:solidFill>
+              </a14:hiddenFill>
+            </a:ext>
+          </a:extLst>
+        </p:spPr>
+      </p:pic>
+      <p:pic>
+        <p:nvPicPr>
+          <p:cNvPr id="2054" name="Picture 6" descr="Kitchen Sink Icons - Free SVG &amp; PNG Kitchen Sink Images - Noun Project">
+            <a:extLst>
+              <a:ext uri="{FF2B5EF4-FFF2-40B4-BE49-F238E27FC236}">
+                <a16:creationId xmlns:a16="http://schemas.microsoft.com/office/drawing/2014/main" id="{2E9F5BCF-C572-B18F-E88B-36C85D1E06B5}"/>
+              </a:ext>
+            </a:extLst>
+          </p:cNvPr>
+          <p:cNvPicPr>
+            <a:picLocks noChangeAspect="1" noChangeArrowheads="1"/>
+          </p:cNvPicPr>
+          <p:nvPr/>
+        </p:nvPicPr>
+        <p:blipFill>
+          <a:blip r:embed="rId5">
+            <a:extLst>
+              <a:ext uri="{28A0092B-C50C-407E-A947-70E740481C1C}">
+                <a14:useLocalDpi xmlns:a14="http://schemas.microsoft.com/office/drawing/2010/main" val="0"/>
+              </a:ext>
+            </a:extLst>
+          </a:blip>
+          <a:srcRect/>
+          <a:stretch>
+            <a:fillRect/>
+          </a:stretch>
+        </p:blipFill>
+        <p:spPr bwMode="auto">
+          <a:xfrm>
+            <a:off x="2933556" y="3208010"/>
+            <a:ext cx="963728" cy="963728"/>
+          </a:xfrm>
+          <a:prstGeom prst="rect">
+            <a:avLst/>
+          </a:prstGeom>
+          <a:noFill/>
+          <a:extLst>
+            <a:ext uri="{909E8E84-426E-40DD-AFC4-6F175D3DCCD1}">
+              <a14:hiddenFill xmlns:a14="http://schemas.microsoft.com/office/drawing/2010/main">
+                <a:solidFill>
+                  <a:srgbClr val="FFFFFF"/>
+                </a:solidFill>
+              </a14:hiddenFill>
+            </a:ext>
+          </a:extLst>
+        </p:spPr>
+      </p:pic>
+    </p:spTree>
+    <p:extLst>
+      <p:ext uri="{BB962C8B-B14F-4D97-AF65-F5344CB8AC3E}">
+        <p14:creationId xmlns:p14="http://schemas.microsoft.com/office/powerpoint/2010/main" val="3753983661"/>
       </p:ext>
     </p:extLst>
   </p:cSld>
@@ -10423,4 +13078,319 @@
     </a:ext>
   </a:extLst>
 </a:theme>
+</file>
+
+<file path=ppt/theme/theme2.xml><?xml version="1.0" encoding="utf-8"?>
+<a:theme xmlns:a="http://schemas.openxmlformats.org/drawingml/2006/main" name="Office Theme">
+  <a:themeElements>
+    <a:clrScheme name="Office">
+      <a:dk1>
+        <a:sysClr val="windowText" lastClr="000000"/>
+      </a:dk1>
+      <a:lt1>
+        <a:sysClr val="window" lastClr="FFFFFF"/>
+      </a:lt1>
+      <a:dk2>
+        <a:srgbClr val="0E2841"/>
+      </a:dk2>
+      <a:lt2>
+        <a:srgbClr val="E8E8E8"/>
+      </a:lt2>
+      <a:accent1>
+        <a:srgbClr val="156082"/>
+      </a:accent1>
+      <a:accent2>
+        <a:srgbClr val="E97132"/>
+      </a:accent2>
+      <a:accent3>
+        <a:srgbClr val="196B24"/>
+      </a:accent3>
+      <a:accent4>
+        <a:srgbClr val="0F9ED5"/>
+      </a:accent4>
+      <a:accent5>
+        <a:srgbClr val="A02B93"/>
+      </a:accent5>
+      <a:accent6>
+        <a:srgbClr val="4EA72E"/>
+      </a:accent6>
+      <a:hlink>
+        <a:srgbClr val="467886"/>
+      </a:hlink>
+      <a:folHlink>
+        <a:srgbClr val="96607D"/>
+      </a:folHlink>
+    </a:clrScheme>
+    <a:fontScheme name="Office">
+      <a:majorFont>
+        <a:latin typeface="Aptos Display" panose="02110004020202020204"/>
+        <a:ea typeface=""/>
+        <a:cs typeface=""/>
+        <a:font script="Jpan" typeface="游ゴシック Light"/>
+        <a:font script="Hang" typeface="맑은 고딕"/>
+        <a:font script="Hans" typeface="等线 Light"/>
+        <a:font script="Hant" typeface="新細明體"/>
+        <a:font script="Arab" typeface="Times New Roman"/>
+        <a:font script="Hebr" typeface="Times New Roman"/>
+        <a:font script="Thai" typeface="Angsana New"/>
+        <a:font script="Ethi" typeface="Nyala"/>
+        <a:font script="Beng" typeface="Vrinda"/>
+        <a:font script="Gujr" typeface="Shruti"/>
+        <a:font script="Khmr" typeface="MoolBoran"/>
+        <a:font script="Knda" typeface="Tunga"/>
+        <a:font script="Guru" typeface="Raavi"/>
+        <a:font script="Cans" typeface="Euphemia"/>
+        <a:font script="Cher" typeface="Plantagenet Cherokee"/>
+        <a:font script="Yiii" typeface="Microsoft Yi Baiti"/>
+        <a:font script="Tibt" typeface="Microsoft Himalaya"/>
+        <a:font script="Thaa" typeface="MV Boli"/>
+        <a:font script="Deva" typeface="Mangal"/>
+        <a:font script="Telu" typeface="Gautami"/>
+        <a:font script="Taml" typeface="Latha"/>
+        <a:font script="Syrc" typeface="Estrangelo Edessa"/>
+        <a:font script="Orya" typeface="Kalinga"/>
+        <a:font script="Mlym" typeface="Kartika"/>
+        <a:font script="Laoo" typeface="DokChampa"/>
+        <a:font script="Sinh" typeface="Iskoola Pota"/>
+        <a:font script="Mong" typeface="Mongolian Baiti"/>
+        <a:font script="Viet" typeface="Times New Roman"/>
+        <a:font script="Uigh" typeface="Microsoft Uighur"/>
+        <a:font script="Geor" typeface="Sylfaen"/>
+        <a:font script="Armn" typeface="Arial"/>
+        <a:font script="Bugi" typeface="Leelawadee UI"/>
+        <a:font script="Bopo" typeface="Microsoft JhengHei"/>
+        <a:font script="Java" typeface="Javanese Text"/>
+        <a:font script="Lisu" typeface="Segoe UI"/>
+        <a:font script="Mymr" typeface="Myanmar Text"/>
+        <a:font script="Nkoo" typeface="Ebrima"/>
+        <a:font script="Olck" typeface="Nirmala UI"/>
+        <a:font script="Osma" typeface="Ebrima"/>
+        <a:font script="Phag" typeface="Phagspa"/>
+        <a:font script="Syrn" typeface="Estrangelo Edessa"/>
+        <a:font script="Syrj" typeface="Estrangelo Edessa"/>
+        <a:font script="Syre" typeface="Estrangelo Edessa"/>
+        <a:font script="Sora" typeface="Nirmala UI"/>
+        <a:font script="Tale" typeface="Microsoft Tai Le"/>
+        <a:font script="Talu" typeface="Microsoft New Tai Lue"/>
+        <a:font script="Tfng" typeface="Ebrima"/>
+      </a:majorFont>
+      <a:minorFont>
+        <a:latin typeface="Aptos" panose="02110004020202020204"/>
+        <a:ea typeface=""/>
+        <a:cs typeface=""/>
+        <a:font script="Jpan" typeface="游ゴシック"/>
+        <a:font script="Hang" typeface="맑은 고딕"/>
+        <a:font script="Hans" typeface="等线"/>
+        <a:font script="Hant" typeface="新細明體"/>
+        <a:font script="Arab" typeface="Arial"/>
+        <a:font script="Hebr" typeface="Arial"/>
+        <a:font script="Thai" typeface="Cordia New"/>
+        <a:font script="Ethi" typeface="Nyala"/>
+        <a:font script="Beng" typeface="Vrinda"/>
+        <a:font script="Gujr" typeface="Shruti"/>
+        <a:font script="Khmr" typeface="DaunPenh"/>
+        <a:font script="Knda" typeface="Tunga"/>
+        <a:font script="Guru" typeface="Raavi"/>
+        <a:font script="Cans" typeface="Euphemia"/>
+        <a:font script="Cher" typeface="Plantagenet Cherokee"/>
+        <a:font script="Yiii" typeface="Microsoft Yi Baiti"/>
+        <a:font script="Tibt" typeface="Microsoft Himalaya"/>
+        <a:font script="Thaa" typeface="MV Boli"/>
+        <a:font script="Deva" typeface="Mangal"/>
+        <a:font script="Telu" typeface="Gautami"/>
+        <a:font script="Taml" typeface="Latha"/>
+        <a:font script="Syrc" typeface="Estrangelo Edessa"/>
+        <a:font script="Orya" typeface="Kalinga"/>
+        <a:font script="Mlym" typeface="Kartika"/>
+        <a:font script="Laoo" typeface="DokChampa"/>
+        <a:font script="Sinh" typeface="Iskoola Pota"/>
+        <a:font script="Mong" typeface="Mongolian Baiti"/>
+        <a:font script="Viet" typeface="Arial"/>
+        <a:font script="Uigh" typeface="Microsoft Uighur"/>
+        <a:font script="Geor" typeface="Sylfaen"/>
+        <a:font script="Armn" typeface="Arial"/>
+        <a:font script="Bugi" typeface="Leelawadee UI"/>
+        <a:font script="Bopo" typeface="Microsoft JhengHei"/>
+        <a:font script="Java" typeface="Javanese Text"/>
+        <a:font script="Lisu" typeface="Segoe UI"/>
+        <a:font script="Mymr" typeface="Myanmar Text"/>
+        <a:font script="Nkoo" typeface="Ebrima"/>
+        <a:font script="Olck" typeface="Nirmala UI"/>
+        <a:font script="Osma" typeface="Ebrima"/>
+        <a:font script="Phag" typeface="Phagspa"/>
+        <a:font script="Syrn" typeface="Estrangelo Edessa"/>
+        <a:font script="Syrj" typeface="Estrangelo Edessa"/>
+        <a:font script="Syre" typeface="Estrangelo Edessa"/>
+        <a:font script="Sora" typeface="Nirmala UI"/>
+        <a:font script="Tale" typeface="Microsoft Tai Le"/>
+        <a:font script="Talu" typeface="Microsoft New Tai Lue"/>
+        <a:font script="Tfng" typeface="Ebrima"/>
+      </a:minorFont>
+    </a:fontScheme>
+    <a:fmtScheme name="Office">
+      <a:fillStyleLst>
+        <a:solidFill>
+          <a:schemeClr val="phClr"/>
+        </a:solidFill>
+        <a:gradFill rotWithShape="1">
+          <a:gsLst>
+            <a:gs pos="0">
+              <a:schemeClr val="phClr">
+                <a:lumMod val="110000"/>
+                <a:satMod val="105000"/>
+                <a:tint val="67000"/>
+              </a:schemeClr>
+            </a:gs>
+            <a:gs pos="50000">
+              <a:schemeClr val="phClr">
+                <a:lumMod val="105000"/>
+                <a:satMod val="103000"/>
+                <a:tint val="73000"/>
+              </a:schemeClr>
+            </a:gs>
+            <a:gs pos="100000">
+              <a:schemeClr val="phClr">
+                <a:lumMod val="105000"/>
+                <a:satMod val="109000"/>
+                <a:tint val="81000"/>
+              </a:schemeClr>
+            </a:gs>
+          </a:gsLst>
+          <a:lin ang="5400000" scaled="0"/>
+        </a:gradFill>
+        <a:gradFill rotWithShape="1">
+          <a:gsLst>
+            <a:gs pos="0">
+              <a:schemeClr val="phClr">
+                <a:satMod val="103000"/>
+                <a:lumMod val="102000"/>
+                <a:tint val="94000"/>
+              </a:schemeClr>
+            </a:gs>
+            <a:gs pos="50000">
+              <a:schemeClr val="phClr">
+                <a:satMod val="110000"/>
+                <a:lumMod val="100000"/>
+                <a:shade val="100000"/>
+              </a:schemeClr>
+            </a:gs>
+            <a:gs pos="100000">
+              <a:schemeClr val="phClr">
+                <a:lumMod val="99000"/>
+                <a:satMod val="120000"/>
+                <a:shade val="78000"/>
+              </a:schemeClr>
+            </a:gs>
+          </a:gsLst>
+          <a:lin ang="5400000" scaled="0"/>
+        </a:gradFill>
+      </a:fillStyleLst>
+      <a:lnStyleLst>
+        <a:ln w="12700" cap="flat" cmpd="sng" algn="ctr">
+          <a:solidFill>
+            <a:schemeClr val="phClr"/>
+          </a:solidFill>
+          <a:prstDash val="solid"/>
+          <a:miter lim="800000"/>
+        </a:ln>
+        <a:ln w="19050" cap="flat" cmpd="sng" algn="ctr">
+          <a:solidFill>
+            <a:schemeClr val="phClr"/>
+          </a:solidFill>
+          <a:prstDash val="solid"/>
+          <a:miter lim="800000"/>
+        </a:ln>
+        <a:ln w="25400" cap="flat" cmpd="sng" algn="ctr">
+          <a:solidFill>
+            <a:schemeClr val="phClr"/>
+          </a:solidFill>
+          <a:prstDash val="solid"/>
+          <a:miter lim="800000"/>
+        </a:ln>
+      </a:lnStyleLst>
+      <a:effectStyleLst>
+        <a:effectStyle>
+          <a:effectLst/>
+        </a:effectStyle>
+        <a:effectStyle>
+          <a:effectLst/>
+        </a:effectStyle>
+        <a:effectStyle>
+          <a:effectLst>
+            <a:outerShdw blurRad="57150" dist="19050" dir="5400000" algn="ctr" rotWithShape="0">
+              <a:srgbClr val="000000">
+                <a:alpha val="63000"/>
+              </a:srgbClr>
+            </a:outerShdw>
+          </a:effectLst>
+        </a:effectStyle>
+      </a:effectStyleLst>
+      <a:bgFillStyleLst>
+        <a:solidFill>
+          <a:schemeClr val="phClr"/>
+        </a:solidFill>
+        <a:solidFill>
+          <a:schemeClr val="phClr">
+            <a:tint val="95000"/>
+            <a:satMod val="170000"/>
+          </a:schemeClr>
+        </a:solidFill>
+        <a:gradFill rotWithShape="1">
+          <a:gsLst>
+            <a:gs pos="0">
+              <a:schemeClr val="phClr">
+                <a:tint val="93000"/>
+                <a:satMod val="150000"/>
+                <a:shade val="98000"/>
+                <a:lumMod val="102000"/>
+              </a:schemeClr>
+            </a:gs>
+            <a:gs pos="50000">
+              <a:schemeClr val="phClr">
+                <a:tint val="98000"/>
+                <a:satMod val="130000"/>
+                <a:shade val="90000"/>
+                <a:lumMod val="103000"/>
+              </a:schemeClr>
+            </a:gs>
+            <a:gs pos="100000">
+              <a:schemeClr val="phClr">
+                <a:shade val="63000"/>
+                <a:satMod val="120000"/>
+              </a:schemeClr>
+            </a:gs>
+          </a:gsLst>
+          <a:lin ang="5400000" scaled="0"/>
+        </a:gradFill>
+      </a:bgFillStyleLst>
+    </a:fmtScheme>
+  </a:themeElements>
+  <a:objectDefaults>
+    <a:lnDef>
+      <a:spPr/>
+      <a:bodyPr/>
+      <a:lstStyle/>
+      <a:style>
+        <a:lnRef idx="2">
+          <a:schemeClr val="accent1"/>
+        </a:lnRef>
+        <a:fillRef idx="0">
+          <a:schemeClr val="accent1"/>
+        </a:fillRef>
+        <a:effectRef idx="1">
+          <a:schemeClr val="accent1"/>
+        </a:effectRef>
+        <a:fontRef idx="minor">
+          <a:schemeClr val="tx1"/>
+        </a:fontRef>
+      </a:style>
+    </a:lnDef>
+  </a:objectDefaults>
+  <a:extraClrSchemeLst/>
+  <a:extLst>
+    <a:ext uri="{05A4C25C-085E-4340-85A3-A5531E510DB2}">
+      <thm15:themeFamily xmlns:thm15="http://schemas.microsoft.com/office/thememl/2012/main" name="Office Theme" id="{2E142A2C-CD16-42D6-873A-C26D2A0506FA}" vid="{1BDDFF52-6CD6-40A5-AB3C-68EB2F1E4D0A}"/>
+    </a:ext>
+  </a:extLst>
+</a:theme>
 </file>
</xml_diff>